<commit_message>
Updates for fall session and slide improvements and corrections
</commit_message>
<xml_diff>
--- a/slides/1_Introduction.pptx
+++ b/slides/1_Introduction.pptx
@@ -17,8 +17,8 @@
     <p:sldId id="782" r:id="rId8"/>
     <p:sldId id="712" r:id="rId9"/>
     <p:sldId id="794" r:id="rId10"/>
-    <p:sldId id="733" r:id="rId11"/>
-    <p:sldId id="788" r:id="rId12"/>
+    <p:sldId id="788" r:id="rId11"/>
+    <p:sldId id="795" r:id="rId12"/>
     <p:sldId id="724" r:id="rId13"/>
     <p:sldId id="397" r:id="rId14"/>
     <p:sldId id="718" r:id="rId15"/>
@@ -36,10 +36,10 @@
     <p:sldId id="722" r:id="rId27"/>
     <p:sldId id="402" r:id="rId28"/>
     <p:sldId id="789" r:id="rId29"/>
-    <p:sldId id="395" r:id="rId30"/>
-    <p:sldId id="793" r:id="rId31"/>
-    <p:sldId id="725" r:id="rId32"/>
-    <p:sldId id="401" r:id="rId33"/>
+    <p:sldId id="401" r:id="rId30"/>
+    <p:sldId id="395" r:id="rId31"/>
+    <p:sldId id="793" r:id="rId32"/>
+    <p:sldId id="725" r:id="rId33"/>
     <p:sldId id="713" r:id="rId34"/>
     <p:sldId id="784" r:id="rId35"/>
     <p:sldId id="387" r:id="rId36"/>
@@ -259,7 +259,7 @@
           <a:p>
             <a:fld id="{2F3ABF1A-8818-4472-8518-E71DC7B5D2F7}" type="datetimeFigureOut">
               <a:rPr lang="en-US" smtClean="0"/>
-              <a:t>6/23/2026</a:t>
+              <a:t>9/2/2026</a:t>
             </a:fld>
             <a:endParaRPr lang="en-US"/>
           </a:p>
@@ -891,7 +891,7 @@
           <a:p>
             <a:fld id="{6E4A31BF-7266-4BEB-918B-ADC21C630A6F}" type="datetimeFigureOut">
               <a:rPr lang="en-US" smtClean="0"/>
-              <a:t>6/23/2026</a:t>
+              <a:t>9/2/2026</a:t>
             </a:fld>
             <a:endParaRPr lang="en-US"/>
           </a:p>
@@ -1089,7 +1089,7 @@
           <a:p>
             <a:fld id="{6E4A31BF-7266-4BEB-918B-ADC21C630A6F}" type="datetimeFigureOut">
               <a:rPr lang="en-US" smtClean="0"/>
-              <a:t>6/23/2026</a:t>
+              <a:t>9/2/2026</a:t>
             </a:fld>
             <a:endParaRPr lang="en-US"/>
           </a:p>
@@ -1297,7 +1297,7 @@
           <a:p>
             <a:fld id="{6E4A31BF-7266-4BEB-918B-ADC21C630A6F}" type="datetimeFigureOut">
               <a:rPr lang="en-US" smtClean="0"/>
-              <a:t>6/23/2026</a:t>
+              <a:t>9/2/2026</a:t>
             </a:fld>
             <a:endParaRPr lang="en-US"/>
           </a:p>
@@ -1841,7 +1841,7 @@
           <a:p>
             <a:fld id="{6E4A31BF-7266-4BEB-918B-ADC21C630A6F}" type="datetimeFigureOut">
               <a:rPr lang="en-US" smtClean="0"/>
-              <a:t>6/23/2026</a:t>
+              <a:t>9/2/2026</a:t>
             </a:fld>
             <a:endParaRPr lang="en-US"/>
           </a:p>
@@ -2116,7 +2116,7 @@
           <a:p>
             <a:fld id="{6E4A31BF-7266-4BEB-918B-ADC21C630A6F}" type="datetimeFigureOut">
               <a:rPr lang="en-US" smtClean="0"/>
-              <a:t>6/23/2026</a:t>
+              <a:t>9/2/2026</a:t>
             </a:fld>
             <a:endParaRPr lang="en-US"/>
           </a:p>
@@ -2381,7 +2381,7 @@
           <a:p>
             <a:fld id="{6E4A31BF-7266-4BEB-918B-ADC21C630A6F}" type="datetimeFigureOut">
               <a:rPr lang="en-US" smtClean="0"/>
-              <a:t>6/23/2026</a:t>
+              <a:t>9/2/2026</a:t>
             </a:fld>
             <a:endParaRPr lang="en-US"/>
           </a:p>
@@ -2793,7 +2793,7 @@
           <a:p>
             <a:fld id="{6E4A31BF-7266-4BEB-918B-ADC21C630A6F}" type="datetimeFigureOut">
               <a:rPr lang="en-US" smtClean="0"/>
-              <a:t>6/23/2026</a:t>
+              <a:t>9/2/2026</a:t>
             </a:fld>
             <a:endParaRPr lang="en-US"/>
           </a:p>
@@ -2934,7 +2934,7 @@
           <a:p>
             <a:fld id="{6E4A31BF-7266-4BEB-918B-ADC21C630A6F}" type="datetimeFigureOut">
               <a:rPr lang="en-US" smtClean="0"/>
-              <a:t>6/23/2026</a:t>
+              <a:t>9/2/2026</a:t>
             </a:fld>
             <a:endParaRPr lang="en-US"/>
           </a:p>
@@ -3047,7 +3047,7 @@
           <a:p>
             <a:fld id="{6E4A31BF-7266-4BEB-918B-ADC21C630A6F}" type="datetimeFigureOut">
               <a:rPr lang="en-US" smtClean="0"/>
-              <a:t>6/23/2026</a:t>
+              <a:t>9/2/2026</a:t>
             </a:fld>
             <a:endParaRPr lang="en-US"/>
           </a:p>
@@ -3358,7 +3358,7 @@
           <a:p>
             <a:fld id="{6E4A31BF-7266-4BEB-918B-ADC21C630A6F}" type="datetimeFigureOut">
               <a:rPr lang="en-US" smtClean="0"/>
-              <a:t>6/23/2026</a:t>
+              <a:t>9/2/2026</a:t>
             </a:fld>
             <a:endParaRPr lang="en-US"/>
           </a:p>
@@ -3646,7 +3646,7 @@
           <a:p>
             <a:fld id="{6E4A31BF-7266-4BEB-918B-ADC21C630A6F}" type="datetimeFigureOut">
               <a:rPr lang="en-US" smtClean="0"/>
-              <a:t>6/23/2026</a:t>
+              <a:t>9/2/2026</a:t>
             </a:fld>
             <a:endParaRPr lang="en-US"/>
           </a:p>
@@ -3887,7 +3887,7 @@
           <a:p>
             <a:fld id="{6E4A31BF-7266-4BEB-918B-ADC21C630A6F}" type="datetimeFigureOut">
               <a:rPr lang="en-US" smtClean="0"/>
-              <a:t>6/23/2026</a:t>
+              <a:t>9/2/2026</a:t>
             </a:fld>
             <a:endParaRPr lang="en-US"/>
           </a:p>
@@ -4520,171 +4520,6 @@
       </p:grpSpPr>
       <p:sp>
         <p:nvSpPr>
-          <p:cNvPr id="4" name="Title 3">
-            <a:extLst>
-              <a:ext uri="{FF2B5EF4-FFF2-40B4-BE49-F238E27FC236}">
-                <a16:creationId xmlns:a16="http://schemas.microsoft.com/office/drawing/2014/main" id="{1BCE2B5B-E165-AFE7-3BF6-9F7655565AD7}"/>
-              </a:ext>
-            </a:extLst>
-          </p:cNvPr>
-          <p:cNvSpPr>
-            <a:spLocks noGrp="1"/>
-          </p:cNvSpPr>
-          <p:nvPr>
-            <p:ph type="title"/>
-          </p:nvPr>
-        </p:nvSpPr>
-        <p:spPr/>
-        <p:txBody>
-          <a:bodyPr>
-            <a:normAutofit/>
-          </a:bodyPr>
-          <a:lstStyle/>
-          <a:p>
-            <a:r>
-              <a:rPr lang="en-DE" sz="3600" dirty="0">
-                <a:latin typeface="+mn-lt"/>
-              </a:rPr>
-              <a:t>About your TA: Jacqueline Hardy</a:t>
-            </a:r>
-          </a:p>
-        </p:txBody>
-      </p:sp>
-      <p:sp>
-        <p:nvSpPr>
-          <p:cNvPr id="5" name="Content Placeholder 4">
-            <a:extLst>
-              <a:ext uri="{FF2B5EF4-FFF2-40B4-BE49-F238E27FC236}">
-                <a16:creationId xmlns:a16="http://schemas.microsoft.com/office/drawing/2014/main" id="{0E53D9F3-C1CB-AE91-44FA-A9A184CF447C}"/>
-              </a:ext>
-            </a:extLst>
-          </p:cNvPr>
-          <p:cNvSpPr>
-            <a:spLocks noGrp="1"/>
-          </p:cNvSpPr>
-          <p:nvPr>
-            <p:ph idx="1"/>
-          </p:nvPr>
-        </p:nvSpPr>
-        <p:spPr/>
-        <p:txBody>
-          <a:bodyPr>
-            <a:normAutofit fontScale="92500" lnSpcReduction="20000"/>
-          </a:bodyPr>
-          <a:lstStyle/>
-          <a:p>
-            <a:r>
-              <a:rPr lang="en-DE" dirty="0"/>
-              <a:t>Bachelor’s Degree from Harvard Extension School (2015-2018)</a:t>
-            </a:r>
-          </a:p>
-          <a:p>
-            <a:pPr lvl="1"/>
-            <a:r>
-              <a:rPr lang="en-DE" dirty="0"/>
-              <a:t>Field of Study: International Relations</a:t>
-            </a:r>
-          </a:p>
-          <a:p>
-            <a:pPr lvl="1"/>
-            <a:r>
-              <a:rPr lang="en-DE" dirty="0"/>
-              <a:t>Minors: Quantitative Analysis &amp; Government</a:t>
-            </a:r>
-          </a:p>
-          <a:p>
-            <a:r>
-              <a:rPr lang="en-DE" dirty="0"/>
-              <a:t>Master’s Degree from Harvard Extension School (2022-2024)</a:t>
-            </a:r>
-          </a:p>
-          <a:p>
-            <a:pPr lvl="1"/>
-            <a:r>
-              <a:rPr lang="en-DE" dirty="0"/>
-              <a:t>Field of Study: Data Science</a:t>
-            </a:r>
-          </a:p>
-          <a:p>
-            <a:r>
-              <a:rPr lang="en-DE" dirty="0"/>
-              <a:t>LG Electronics: </a:t>
-            </a:r>
-          </a:p>
-          <a:p>
-            <a:pPr lvl="1"/>
-            <a:r>
-              <a:rPr lang="en-DE" dirty="0"/>
-              <a:t>Product Specialist </a:t>
-            </a:r>
-          </a:p>
-          <a:p>
-            <a:pPr lvl="1"/>
-            <a:r>
-              <a:rPr lang="en-DE" dirty="0"/>
-              <a:t>Go-to-Market Manager</a:t>
-            </a:r>
-          </a:p>
-          <a:p>
-            <a:pPr lvl="1"/>
-            <a:r>
-              <a:rPr lang="en-DE" dirty="0"/>
-              <a:t>Data Analytics Specialist </a:t>
-            </a:r>
-          </a:p>
-          <a:p>
-            <a:r>
-              <a:rPr lang="en-DE" dirty="0"/>
-              <a:t>SharkNinja </a:t>
-            </a:r>
-          </a:p>
-          <a:p>
-            <a:pPr lvl="1"/>
-            <a:r>
-              <a:rPr lang="en-DE" dirty="0"/>
-              <a:t>Strategic Planning and Operations Data Scientist </a:t>
-            </a:r>
-          </a:p>
-          <a:p>
-            <a:r>
-              <a:rPr lang="en-DE" dirty="0"/>
-              <a:t>Building my own Data Science Consulting Firm</a:t>
-            </a:r>
-          </a:p>
-        </p:txBody>
-      </p:sp>
-    </p:spTree>
-    <p:extLst>
-      <p:ext uri="{BB962C8B-B14F-4D97-AF65-F5344CB8AC3E}">
-        <p14:creationId xmlns:p14="http://schemas.microsoft.com/office/powerpoint/2010/main" val="2292487268"/>
-      </p:ext>
-    </p:extLst>
-  </p:cSld>
-  <p:clrMapOvr>
-    <a:masterClrMapping/>
-  </p:clrMapOvr>
-</p:sld>
-</file>
-
-<file path=ppt/slides/slide11.xml><?xml version="1.0" encoding="utf-8"?>
-<p:sld xmlns:a="http://schemas.openxmlformats.org/drawingml/2006/main" xmlns:r="http://schemas.openxmlformats.org/officeDocument/2006/relationships" xmlns:p="http://schemas.openxmlformats.org/presentationml/2006/main">
-  <p:cSld>
-    <p:spTree>
-      <p:nvGrpSpPr>
-        <p:cNvPr id="1" name=""/>
-        <p:cNvGrpSpPr/>
-        <p:nvPr/>
-      </p:nvGrpSpPr>
-      <p:grpSpPr>
-        <a:xfrm>
-          <a:off x="0" y="0"/>
-          <a:ext cx="0" cy="0"/>
-          <a:chOff x="0" y="0"/>
-          <a:chExt cx="0" cy="0"/>
-        </a:xfrm>
-      </p:grpSpPr>
-      <p:sp>
-        <p:nvSpPr>
           <p:cNvPr id="66" name="PlaceHolder 1"/>
           <p:cNvSpPr>
             <a:spLocks noGrp="1"/>
@@ -4933,6 +4768,162 @@
               </a:solidFill>
               <a:latin typeface="+mn-lt"/>
             </a:endParaRPr>
+          </a:p>
+        </p:txBody>
+      </p:sp>
+    </p:spTree>
+  </p:cSld>
+  <p:clrMapOvr>
+    <a:masterClrMapping/>
+  </p:clrMapOvr>
+</p:sld>
+</file>
+
+<file path=ppt/slides/slide11.xml><?xml version="1.0" encoding="utf-8"?>
+<p:sld xmlns:a="http://schemas.openxmlformats.org/drawingml/2006/main" xmlns:r="http://schemas.openxmlformats.org/officeDocument/2006/relationships" xmlns:p="http://schemas.openxmlformats.org/presentationml/2006/main">
+  <p:cSld>
+    <p:spTree>
+      <p:nvGrpSpPr>
+        <p:cNvPr id="1" name=""/>
+        <p:cNvGrpSpPr/>
+        <p:nvPr/>
+      </p:nvGrpSpPr>
+      <p:grpSpPr>
+        <a:xfrm>
+          <a:off x="0" y="0"/>
+          <a:ext cx="0" cy="0"/>
+          <a:chOff x="0" y="0"/>
+          <a:chExt cx="0" cy="0"/>
+        </a:xfrm>
+      </p:grpSpPr>
+      <p:sp>
+        <p:nvSpPr>
+          <p:cNvPr id="2" name="Title 1">
+            <a:extLst>
+              <a:ext uri="{FF2B5EF4-FFF2-40B4-BE49-F238E27FC236}">
+                <a16:creationId xmlns:a16="http://schemas.microsoft.com/office/drawing/2014/main" id="{3B3EA3CE-8DB0-40A5-B4A6-AFCE2156CC1F}"/>
+              </a:ext>
+            </a:extLst>
+          </p:cNvPr>
+          <p:cNvSpPr>
+            <a:spLocks noGrp="1"/>
+          </p:cNvSpPr>
+          <p:nvPr>
+            <p:ph type="title"/>
+          </p:nvPr>
+        </p:nvSpPr>
+        <p:spPr>
+          <a:xfrm>
+            <a:off x="1011194" y="599904"/>
+            <a:ext cx="10515600" cy="486573"/>
+          </a:xfrm>
+        </p:spPr>
+        <p:txBody>
+          <a:bodyPr>
+            <a:noAutofit/>
+          </a:bodyPr>
+          <a:lstStyle/>
+          <a:p>
+            <a:r>
+              <a:rPr lang="en-US" sz="3600" dirty="0">
+                <a:latin typeface="+mn-lt"/>
+              </a:rPr>
+              <a:t>About your TA: Hellen S. Momoh</a:t>
+            </a:r>
+          </a:p>
+        </p:txBody>
+      </p:sp>
+      <p:sp>
+        <p:nvSpPr>
+          <p:cNvPr id="3" name="Content Placeholder 2">
+            <a:extLst>
+              <a:ext uri="{FF2B5EF4-FFF2-40B4-BE49-F238E27FC236}">
+                <a16:creationId xmlns:a16="http://schemas.microsoft.com/office/drawing/2014/main" id="{CA03134D-F068-4BC9-B038-F3D5CBDDE3F9}"/>
+              </a:ext>
+            </a:extLst>
+          </p:cNvPr>
+          <p:cNvSpPr>
+            <a:spLocks noGrp="1"/>
+          </p:cNvSpPr>
+          <p:nvPr>
+            <p:ph idx="1"/>
+          </p:nvPr>
+        </p:nvSpPr>
+        <p:spPr>
+          <a:xfrm>
+            <a:off x="647392" y="1398657"/>
+            <a:ext cx="10515600" cy="4538867"/>
+          </a:xfrm>
+        </p:spPr>
+        <p:txBody>
+          <a:bodyPr>
+            <a:noAutofit/>
+          </a:bodyPr>
+          <a:lstStyle/>
+          <a:p>
+            <a:pPr>
+              <a:spcBef>
+                <a:spcPts val="600"/>
+              </a:spcBef>
+            </a:pPr>
+            <a:r>
+              <a:rPr sz="2400" dirty="0"/>
+              <a:t>Data Scientist and AI/ML Engineer developing applied machine learning and intelligent systems</a:t>
+            </a:r>
+          </a:p>
+          <a:p>
+            <a:r>
+              <a:rPr sz="2400" dirty="0"/>
+              <a:t>Founder &amp; CEO of </a:t>
+            </a:r>
+            <a:r>
+              <a:rPr sz="2400" dirty="0" err="1"/>
+              <a:t>Surna</a:t>
+            </a:r>
+            <a:r>
+              <a:rPr sz="2400" dirty="0"/>
+              <a:t> Technologies, building</a:t>
+            </a:r>
+            <a:r>
+              <a:rPr lang="en-US" sz="2400" dirty="0"/>
+              <a:t> sovereign</a:t>
+            </a:r>
+            <a:r>
+              <a:rPr sz="2400" dirty="0"/>
+              <a:t> AI-powered </a:t>
+            </a:r>
+            <a:r>
+              <a:rPr lang="en-US" sz="2400" dirty="0"/>
+              <a:t>systems</a:t>
+            </a:r>
+            <a:r>
+              <a:rPr sz="2400" dirty="0"/>
+              <a:t> and digital infrastructure</a:t>
+            </a:r>
+          </a:p>
+          <a:p>
+            <a:r>
+              <a:rPr sz="2400" dirty="0"/>
+              <a:t>Applied AI experience across financial systems, maternal wellness, and public-sector technology</a:t>
+            </a:r>
+          </a:p>
+          <a:p>
+            <a:r>
+              <a:rPr sz="2400" dirty="0"/>
+              <a:t>ALM in Data Science, Harvard University; BALS in Interdisciplinary Mathematics, Georgetown University</a:t>
+            </a:r>
+          </a:p>
+          <a:p>
+            <a:r>
+              <a:rPr sz="2400" dirty="0"/>
+              <a:t>Professional experience spanning technology, engineering, and international public service</a:t>
+            </a:r>
+          </a:p>
+          <a:p>
+            <a:r>
+              <a:rPr sz="2400" dirty="0"/>
+              <a:t>Passionate about translating data science and machine learning from theory into real-world systems</a:t>
+            </a:r>
           </a:p>
         </p:txBody>
       </p:sp>
@@ -6866,7 +6857,7 @@
                     <m:sSup>
                       <m:sSupPr>
                         <m:ctrlPr>
-                          <a:rPr lang="en-US" i="1" smtClean="0">
+                          <a:rPr lang="en-US" b="0" i="1" smtClean="0">
                             <a:latin typeface="Cambria Math" panose="02040503050406030204" pitchFamily="18" charset="0"/>
                           </a:rPr>
                         </m:ctrlPr>
@@ -11974,7 +11965,9 @@
         </p:nvSpPr>
         <p:spPr/>
         <p:txBody>
-          <a:bodyPr/>
+          <a:bodyPr>
+            <a:normAutofit/>
+          </a:bodyPr>
           <a:lstStyle/>
           <a:p>
             <a:r>
@@ -11983,17 +11976,6 @@
             </a:r>
           </a:p>
           <a:p>
-            <a:pPr lvl="1"/>
-            <a:r>
-              <a:rPr lang="en-US" dirty="0"/>
-              <a:t>Data mining is the science of </a:t>
-            </a:r>
-            <a:r>
-              <a:rPr lang="en-US" b="1" dirty="0"/>
-              <a:t>knowledge discovery  </a:t>
-            </a:r>
-          </a:p>
-          <a:p>
             <a:r>
               <a:rPr lang="en-US" dirty="0"/>
               <a:t>About this course  </a:t>
@@ -12016,11 +11998,15 @@
             <a:pPr lvl="1"/>
             <a:r>
               <a:rPr lang="en-US" dirty="0"/>
-              <a:t>Efficient management of key-value pairs requires hashing </a:t>
-            </a:r>
-          </a:p>
-          <a:p>
-            <a:endParaRPr lang="en-US" dirty="0"/>
+              <a:t>Efficient management of key-value pairs requires hashing</a:t>
+            </a:r>
+          </a:p>
+          <a:p>
+            <a:pPr lvl="1"/>
+            <a:r>
+              <a:rPr lang="en-US" dirty="0"/>
+              <a:t>Hash functions provide direct addressing at a massive scale</a:t>
+            </a:r>
           </a:p>
         </p:txBody>
       </p:sp>
@@ -12141,15 +12127,33 @@
                                   </p:childTnLst>
                                 </p:cTn>
                               </p:par>
+                            </p:childTnLst>
+                          </p:cTn>
+                        </p:par>
+                      </p:childTnLst>
+                    </p:cTn>
+                  </p:par>
+                  <p:par>
+                    <p:cTn id="7" fill="hold">
+                      <p:stCondLst>
+                        <p:cond delay="indefinite"/>
+                      </p:stCondLst>
+                      <p:childTnLst>
+                        <p:par>
+                          <p:cTn id="8" fill="hold">
+                            <p:stCondLst>
+                              <p:cond delay="0"/>
+                            </p:stCondLst>
+                            <p:childTnLst>
                               <p:par>
-                                <p:cTn id="7" presetID="1" presetClass="entr" presetSubtype="0" fill="hold" nodeType="withEffect">
+                                <p:cTn id="9" presetID="1" presetClass="entr" presetSubtype="0" fill="hold" nodeType="clickEffect">
                                   <p:stCondLst>
                                     <p:cond delay="0"/>
                                   </p:stCondLst>
                                   <p:childTnLst>
                                     <p:set>
                                       <p:cBhvr>
-                                        <p:cTn id="8" dur="1" fill="hold">
+                                        <p:cTn id="10" dur="1" fill="hold">
                                           <p:stCondLst>
                                             <p:cond delay="0"/>
                                           </p:stCondLst>
@@ -12179,26 +12183,26 @@
                     </p:cTn>
                   </p:par>
                   <p:par>
-                    <p:cTn id="9" fill="hold">
+                    <p:cTn id="11" fill="hold">
                       <p:stCondLst>
                         <p:cond delay="indefinite"/>
                       </p:stCondLst>
                       <p:childTnLst>
                         <p:par>
-                          <p:cTn id="10" fill="hold">
+                          <p:cTn id="12" fill="hold">
                             <p:stCondLst>
                               <p:cond delay="0"/>
                             </p:stCondLst>
                             <p:childTnLst>
                               <p:par>
-                                <p:cTn id="11" presetID="1" presetClass="entr" presetSubtype="0" fill="hold" nodeType="clickEffect">
+                                <p:cTn id="13" presetID="1" presetClass="entr" presetSubtype="0" fill="hold" nodeType="clickEffect">
                                   <p:stCondLst>
                                     <p:cond delay="0"/>
                                   </p:stCondLst>
                                   <p:childTnLst>
                                     <p:set>
                                       <p:cBhvr>
-                                        <p:cTn id="12" dur="1" fill="hold">
+                                        <p:cTn id="14" dur="1" fill="hold">
                                           <p:stCondLst>
                                             <p:cond delay="0"/>
                                           </p:stCondLst>
@@ -12221,26 +12225,8 @@
                                   </p:childTnLst>
                                 </p:cTn>
                               </p:par>
-                            </p:childTnLst>
-                          </p:cTn>
-                        </p:par>
-                      </p:childTnLst>
-                    </p:cTn>
-                  </p:par>
-                  <p:par>
-                    <p:cTn id="13" fill="hold">
-                      <p:stCondLst>
-                        <p:cond delay="indefinite"/>
-                      </p:stCondLst>
-                      <p:childTnLst>
-                        <p:par>
-                          <p:cTn id="14" fill="hold">
-                            <p:stCondLst>
-                              <p:cond delay="0"/>
-                            </p:stCondLst>
-                            <p:childTnLst>
                               <p:par>
-                                <p:cTn id="15" presetID="1" presetClass="entr" presetSubtype="0" fill="hold" nodeType="clickEffect">
+                                <p:cTn id="15" presetID="1" presetClass="entr" presetSubtype="0" fill="hold" nodeType="withEffect">
                                   <p:stCondLst>
                                     <p:cond delay="0"/>
                                   </p:stCondLst>
@@ -12364,7 +12350,7 @@
 </file>
 
 <file path=ppt/slides/slide20.xml><?xml version="1.0" encoding="utf-8"?>
-<p:sld xmlns:a="http://schemas.openxmlformats.org/drawingml/2006/main" xmlns:r="http://schemas.openxmlformats.org/officeDocument/2006/relationships" xmlns:p="http://schemas.openxmlformats.org/presentationml/2006/main" show="0">
+<p:sld xmlns:a="http://schemas.openxmlformats.org/drawingml/2006/main" xmlns:r="http://schemas.openxmlformats.org/officeDocument/2006/relationships" xmlns:p="http://schemas.openxmlformats.org/presentationml/2006/main">
   <p:cSld>
     <p:spTree>
       <p:nvGrpSpPr>
@@ -12740,7 +12726,7 @@
 </file>
 
 <file path=ppt/slides/slide21.xml><?xml version="1.0" encoding="utf-8"?>
-<p:sld xmlns:a="http://schemas.openxmlformats.org/drawingml/2006/main" xmlns:r="http://schemas.openxmlformats.org/officeDocument/2006/relationships" xmlns:p="http://schemas.openxmlformats.org/presentationml/2006/main">
+<p:sld xmlns:a="http://schemas.openxmlformats.org/drawingml/2006/main" xmlns:r="http://schemas.openxmlformats.org/officeDocument/2006/relationships" xmlns:p="http://schemas.openxmlformats.org/presentationml/2006/main" show="0">
   <p:cSld>
     <p:spTree>
       <p:nvGrpSpPr>
@@ -12789,7 +12775,7 @@
             </a:pPr>
             <a:r>
               <a:rPr lang="en-US" dirty="0"/>
-              <a:t>Schedule for live class meetings </a:t>
+              <a:t>Schedule for live class meetings during Summer School </a:t>
             </a:r>
           </a:p>
           <a:p>
@@ -13172,7 +13158,7 @@
 </file>
 
 <file path=ppt/slides/slide22.xml><?xml version="1.0" encoding="utf-8"?>
-<p:sld xmlns:a="http://schemas.openxmlformats.org/drawingml/2006/main" xmlns:r="http://schemas.openxmlformats.org/officeDocument/2006/relationships" xmlns:p="http://schemas.openxmlformats.org/presentationml/2006/main">
+<p:sld xmlns:a="http://schemas.openxmlformats.org/drawingml/2006/main" xmlns:r="http://schemas.openxmlformats.org/officeDocument/2006/relationships" xmlns:p="http://schemas.openxmlformats.org/presentationml/2006/main" show="0">
   <p:cSld>
     <p:spTree>
       <p:nvGrpSpPr>
@@ -15158,7 +15144,7 @@
             </a:pPr>
             <a:r>
               <a:rPr lang="en-US" dirty="0"/>
-              <a:t>Expect 8 assignment in 7 weeks + project! </a:t>
+              <a:t>Expect 8 assignments + project! </a:t>
             </a:r>
           </a:p>
           <a:p>
@@ -15260,8 +15246,12 @@
           <a:p>
             <a:pPr lvl="1"/>
             <a:r>
-              <a:rPr lang="en-US" dirty="0"/>
-              <a:t>Updated assignment notebooks and slides will be placed in the repository </a:t>
+              <a:rPr lang="en-US" dirty="0">
+                <a:solidFill>
+                  <a:srgbClr val="C00000"/>
+                </a:solidFill>
+              </a:rPr>
+              <a:t>Make sure to work in your own branch or copy to another directory</a:t>
             </a:r>
           </a:p>
           <a:p>
@@ -15779,7 +15769,7 @@
 </file>
 
 <file path=ppt/slides/slide28.xml><?xml version="1.0" encoding="utf-8"?>
-<p:sld xmlns:a="http://schemas.openxmlformats.org/drawingml/2006/main" xmlns:r="http://schemas.openxmlformats.org/officeDocument/2006/relationships" xmlns:p="http://schemas.openxmlformats.org/presentationml/2006/main">
+<p:sld xmlns:a="http://schemas.openxmlformats.org/drawingml/2006/main" xmlns:r="http://schemas.openxmlformats.org/officeDocument/2006/relationships" xmlns:p="http://schemas.openxmlformats.org/presentationml/2006/main" show="0">
   <p:cSld>
     <p:spTree>
       <p:nvGrpSpPr>
@@ -15864,14 +15854,14 @@
             <a:pPr lvl="1"/>
             <a:r>
               <a:rPr lang="en-US" dirty="0"/>
-              <a:t>Up to 2 days late - less 10% </a:t>
+              <a:t>Up to 2 days late - less 20% </a:t>
             </a:r>
           </a:p>
           <a:p>
             <a:pPr lvl="1"/>
             <a:r>
               <a:rPr lang="en-US" dirty="0"/>
-              <a:t>Up to 3 days late – less 20%</a:t>
+              <a:t>Up to 3 days late – less 40%</a:t>
             </a:r>
           </a:p>
           <a:p>
@@ -16281,7 +16271,7 @@
         <p:spPr>
           <a:xfrm>
             <a:off x="838200" y="1324927"/>
-            <a:ext cx="10515600" cy="5311004"/>
+            <a:ext cx="10515600" cy="4898217"/>
           </a:xfrm>
         </p:spPr>
         <p:txBody>
@@ -16294,153 +16284,92 @@
               <a:buNone/>
             </a:pPr>
             <a:r>
+              <a:rPr lang="en-US" dirty="0"/>
+              <a:t>Timely release of assignment solutions is an important part of the learning process </a:t>
+            </a:r>
+          </a:p>
+          <a:p>
+            <a:r>
               <a:rPr lang="en-US" b="1" dirty="0"/>
-              <a:t>Ed Discussion is the primary means of communication </a:t>
+              <a:t>Do not fall behind! </a:t>
             </a:r>
             <a:r>
               <a:rPr lang="en-US" dirty="0"/>
-              <a:t>for this course  </a:t>
-            </a:r>
-          </a:p>
-          <a:p>
-            <a:r>
-              <a:rPr lang="en-US" dirty="0"/>
-              <a:t>Use Ed Discussion to get help with assignments and projects </a:t>
-            </a:r>
-          </a:p>
-          <a:p>
-            <a:pPr lvl="1"/>
-            <a:r>
-              <a:rPr lang="en-US" dirty="0"/>
-              <a:t>It’s </a:t>
-            </a:r>
-            <a:r>
-              <a:rPr lang="en-US" b="1" dirty="0"/>
-              <a:t>okay to post code for your question!</a:t>
-            </a:r>
-          </a:p>
-          <a:p>
-            <a:pPr lvl="1"/>
+              <a:t>With 8 assignments and a project, there is very </a:t>
+            </a:r>
             <a:r>
               <a:rPr lang="en-US" b="1" dirty="0">
                 <a:solidFill>
                   <a:srgbClr val="C00000"/>
                 </a:solidFill>
               </a:rPr>
-              <a:t>Post code and complete exception messages if you are dealing with code problem!</a:t>
-            </a:r>
+              <a:t>little time to “catch-up</a:t>
+            </a:r>
+            <a:r>
+              <a:rPr lang="en-US" b="1" dirty="0"/>
+              <a:t>”</a:t>
+            </a:r>
+            <a:endParaRPr lang="en-US" dirty="0"/>
           </a:p>
           <a:p>
             <a:r>
               <a:rPr lang="en-US" dirty="0"/>
-              <a:t>Graded online class discussions take place in Ed    </a:t>
-            </a:r>
-          </a:p>
-          <a:p>
+              <a:t>Late assignment policy:   </a:t>
+            </a:r>
+          </a:p>
+          <a:p>
+            <a:pPr lvl="1"/>
             <a:r>
               <a:rPr lang="en-US" dirty="0"/>
-              <a:t>Private communications regarding matters such as grades</a:t>
+              <a:t>Up to one day late - no penalty  </a:t>
             </a:r>
           </a:p>
           <a:p>
             <a:pPr lvl="1"/>
             <a:r>
               <a:rPr lang="en-US" dirty="0"/>
-              <a:t>Use private messages in Ed Discussion for fastest response </a:t>
+              <a:t>Up to two days late - less 10% </a:t>
             </a:r>
           </a:p>
           <a:p>
             <a:pPr lvl="1"/>
             <a:r>
               <a:rPr lang="en-US" dirty="0"/>
-              <a:t>Or, Steve Elston: </a:t>
-            </a:r>
-            <a:r>
-              <a:rPr lang="en-US" dirty="0" err="1"/>
-              <a:t>stephen_elston</a:t>
-            </a:r>
+              <a:t>Up to three days late - less 20% </a:t>
+            </a:r>
+          </a:p>
+          <a:p>
+            <a:pPr lvl="1"/>
             <a:r>
               <a:rPr lang="en-US" dirty="0"/>
-              <a:t> at g dot </a:t>
-            </a:r>
-            <a:r>
-              <a:rPr lang="en-US" dirty="0" err="1"/>
-              <a:t>harvard</a:t>
-            </a:r>
+              <a:t>Up to four days late - less 30% </a:t>
+            </a:r>
+          </a:p>
+          <a:p>
+            <a:pPr lvl="1"/>
             <a:r>
               <a:rPr lang="en-US" dirty="0"/>
-              <a:t> dot </a:t>
-            </a:r>
-            <a:r>
-              <a:rPr lang="en-US" dirty="0" err="1"/>
-              <a:t>edu</a:t>
-            </a:r>
+              <a:t>Up to five days late - less 40% </a:t>
+            </a:r>
+          </a:p>
+          <a:p>
+            <a:pPr lvl="1"/>
             <a:r>
               <a:rPr lang="en-US" dirty="0"/>
-              <a:t>, Jacqeline Hardy: </a:t>
-            </a:r>
-            <a:r>
-              <a:rPr lang="en-US" dirty="0" err="1"/>
-              <a:t>jacquelinehardy</a:t>
-            </a:r>
-            <a:r>
-              <a:rPr lang="en-US" dirty="0"/>
-              <a:t> at g dot </a:t>
-            </a:r>
-            <a:r>
-              <a:rPr lang="en-US" dirty="0" err="1"/>
-              <a:t>harvard</a:t>
-            </a:r>
-            <a:r>
-              <a:rPr lang="en-US" dirty="0"/>
-              <a:t> dot </a:t>
-            </a:r>
-            <a:r>
-              <a:rPr lang="en-US" dirty="0" err="1"/>
-              <a:t>edu</a:t>
-            </a:r>
-            <a:r>
-              <a:rPr lang="en-US" dirty="0"/>
-              <a:t>, Eric Trucksess: ert713 at g dot </a:t>
-            </a:r>
-            <a:r>
-              <a:rPr lang="en-US" dirty="0" err="1"/>
-              <a:t>harvard</a:t>
-            </a:r>
-            <a:r>
-              <a:rPr lang="en-US" dirty="0"/>
-              <a:t> dot </a:t>
-            </a:r>
-            <a:r>
-              <a:rPr lang="en-US" dirty="0" err="1"/>
-              <a:t>edu</a:t>
-            </a:r>
-            <a:endParaRPr lang="en-US" b="0" i="0" dirty="0">
-              <a:effectLst/>
-              <a:latin typeface="Google Sans"/>
-            </a:endParaRPr>
-          </a:p>
-          <a:p>
-            <a:pPr lvl="1"/>
-            <a:r>
-              <a:rPr lang="en-US" b="1" dirty="0">
-                <a:latin typeface="Google Sans"/>
-              </a:rPr>
-              <a:t>Private one-on-one appointments on request</a:t>
-            </a:r>
-            <a:endParaRPr lang="en-US" b="1" i="0" dirty="0">
-              <a:effectLst/>
-              <a:latin typeface="Google Sans"/>
-            </a:endParaRPr>
-          </a:p>
-          <a:p>
+              <a:t>More than five days late - no credit   </a:t>
+            </a:r>
+          </a:p>
+          <a:p>
+            <a:pPr marL="0" indent="0">
+              <a:buNone/>
+            </a:pPr>
             <a:r>
               <a:rPr lang="en-US" b="1" dirty="0">
                 <a:solidFill>
                   <a:srgbClr val="C00000"/>
                 </a:solidFill>
               </a:rPr>
-              <a:t>Do not use Canvas messages, unless you want a delayed response!   </a:t>
+              <a:t>Make sure you turn in work on time!</a:t>
             </a:r>
           </a:p>
         </p:txBody>
@@ -16496,7 +16425,7 @@
               <a:rPr lang="en-US" dirty="0">
                 <a:latin typeface="+mn-lt"/>
               </a:rPr>
-              <a:t>Communication </a:t>
+              <a:t>Late Assignment Policy – For regular semester</a:t>
             </a:r>
           </a:p>
         </p:txBody>
@@ -16504,394 +16433,13 @@
     </p:spTree>
     <p:extLst>
       <p:ext uri="{BB962C8B-B14F-4D97-AF65-F5344CB8AC3E}">
-        <p14:creationId xmlns:p14="http://schemas.microsoft.com/office/powerpoint/2010/main" val="1228520043"/>
+        <p14:creationId xmlns:p14="http://schemas.microsoft.com/office/powerpoint/2010/main" val="1424932590"/>
       </p:ext>
     </p:extLst>
   </p:cSld>
   <p:clrMapOvr>
     <a:masterClrMapping/>
   </p:clrMapOvr>
-  <p:timing>
-    <p:tnLst>
-      <p:par>
-        <p:cTn id="1" dur="indefinite" restart="never" nodeType="tmRoot">
-          <p:childTnLst>
-            <p:seq concurrent="1" nextAc="seek">
-              <p:cTn id="2" dur="indefinite" nodeType="mainSeq">
-                <p:childTnLst>
-                  <p:par>
-                    <p:cTn id="3" fill="hold">
-                      <p:stCondLst>
-                        <p:cond delay="indefinite"/>
-                      </p:stCondLst>
-                      <p:childTnLst>
-                        <p:par>
-                          <p:cTn id="4" fill="hold">
-                            <p:stCondLst>
-                              <p:cond delay="0"/>
-                            </p:stCondLst>
-                            <p:childTnLst>
-                              <p:par>
-                                <p:cTn id="5" presetID="1" presetClass="entr" presetSubtype="0" fill="hold" nodeType="clickEffect">
-                                  <p:stCondLst>
-                                    <p:cond delay="0"/>
-                                  </p:stCondLst>
-                                  <p:childTnLst>
-                                    <p:set>
-                                      <p:cBhvr>
-                                        <p:cTn id="6" dur="1" fill="hold">
-                                          <p:stCondLst>
-                                            <p:cond delay="0"/>
-                                          </p:stCondLst>
-                                        </p:cTn>
-                                        <p:tgtEl>
-                                          <p:spTgt spid="3">
-                                            <p:txEl>
-                                              <p:pRg st="1" end="1"/>
-                                            </p:txEl>
-                                          </p:spTgt>
-                                        </p:tgtEl>
-                                        <p:attrNameLst>
-                                          <p:attrName>style.visibility</p:attrName>
-                                        </p:attrNameLst>
-                                      </p:cBhvr>
-                                      <p:to>
-                                        <p:strVal val="visible"/>
-                                      </p:to>
-                                    </p:set>
-                                  </p:childTnLst>
-                                </p:cTn>
-                              </p:par>
-                              <p:par>
-                                <p:cTn id="7" presetID="1" presetClass="entr" presetSubtype="0" fill="hold" nodeType="withEffect">
-                                  <p:stCondLst>
-                                    <p:cond delay="0"/>
-                                  </p:stCondLst>
-                                  <p:childTnLst>
-                                    <p:set>
-                                      <p:cBhvr>
-                                        <p:cTn id="8" dur="1" fill="hold">
-                                          <p:stCondLst>
-                                            <p:cond delay="0"/>
-                                          </p:stCondLst>
-                                        </p:cTn>
-                                        <p:tgtEl>
-                                          <p:spTgt spid="3">
-                                            <p:txEl>
-                                              <p:pRg st="2" end="2"/>
-                                            </p:txEl>
-                                          </p:spTgt>
-                                        </p:tgtEl>
-                                        <p:attrNameLst>
-                                          <p:attrName>style.visibility</p:attrName>
-                                        </p:attrNameLst>
-                                      </p:cBhvr>
-                                      <p:to>
-                                        <p:strVal val="visible"/>
-                                      </p:to>
-                                    </p:set>
-                                  </p:childTnLst>
-                                </p:cTn>
-                              </p:par>
-                              <p:par>
-                                <p:cTn id="9" presetID="1" presetClass="entr" presetSubtype="0" fill="hold" nodeType="withEffect">
-                                  <p:stCondLst>
-                                    <p:cond delay="0"/>
-                                  </p:stCondLst>
-                                  <p:childTnLst>
-                                    <p:set>
-                                      <p:cBhvr>
-                                        <p:cTn id="10" dur="1" fill="hold">
-                                          <p:stCondLst>
-                                            <p:cond delay="0"/>
-                                          </p:stCondLst>
-                                        </p:cTn>
-                                        <p:tgtEl>
-                                          <p:spTgt spid="3">
-                                            <p:txEl>
-                                              <p:pRg st="3" end="3"/>
-                                            </p:txEl>
-                                          </p:spTgt>
-                                        </p:tgtEl>
-                                        <p:attrNameLst>
-                                          <p:attrName>style.visibility</p:attrName>
-                                        </p:attrNameLst>
-                                      </p:cBhvr>
-                                      <p:to>
-                                        <p:strVal val="visible"/>
-                                      </p:to>
-                                    </p:set>
-                                  </p:childTnLst>
-                                </p:cTn>
-                              </p:par>
-                            </p:childTnLst>
-                          </p:cTn>
-                        </p:par>
-                      </p:childTnLst>
-                    </p:cTn>
-                  </p:par>
-                  <p:par>
-                    <p:cTn id="11" fill="hold">
-                      <p:stCondLst>
-                        <p:cond delay="indefinite"/>
-                      </p:stCondLst>
-                      <p:childTnLst>
-                        <p:par>
-                          <p:cTn id="12" fill="hold">
-                            <p:stCondLst>
-                              <p:cond delay="0"/>
-                            </p:stCondLst>
-                            <p:childTnLst>
-                              <p:par>
-                                <p:cTn id="13" presetID="1" presetClass="entr" presetSubtype="0" fill="hold" nodeType="clickEffect">
-                                  <p:stCondLst>
-                                    <p:cond delay="0"/>
-                                  </p:stCondLst>
-                                  <p:childTnLst>
-                                    <p:set>
-                                      <p:cBhvr>
-                                        <p:cTn id="14" dur="1" fill="hold">
-                                          <p:stCondLst>
-                                            <p:cond delay="0"/>
-                                          </p:stCondLst>
-                                        </p:cTn>
-                                        <p:tgtEl>
-                                          <p:spTgt spid="3">
-                                            <p:txEl>
-                                              <p:pRg st="4" end="4"/>
-                                            </p:txEl>
-                                          </p:spTgt>
-                                        </p:tgtEl>
-                                        <p:attrNameLst>
-                                          <p:attrName>style.visibility</p:attrName>
-                                        </p:attrNameLst>
-                                      </p:cBhvr>
-                                      <p:to>
-                                        <p:strVal val="visible"/>
-                                      </p:to>
-                                    </p:set>
-                                  </p:childTnLst>
-                                </p:cTn>
-                              </p:par>
-                            </p:childTnLst>
-                          </p:cTn>
-                        </p:par>
-                      </p:childTnLst>
-                    </p:cTn>
-                  </p:par>
-                  <p:par>
-                    <p:cTn id="15" fill="hold">
-                      <p:stCondLst>
-                        <p:cond delay="indefinite"/>
-                      </p:stCondLst>
-                      <p:childTnLst>
-                        <p:par>
-                          <p:cTn id="16" fill="hold">
-                            <p:stCondLst>
-                              <p:cond delay="0"/>
-                            </p:stCondLst>
-                            <p:childTnLst>
-                              <p:par>
-                                <p:cTn id="17" presetID="1" presetClass="entr" presetSubtype="0" fill="hold" nodeType="clickEffect">
-                                  <p:stCondLst>
-                                    <p:cond delay="0"/>
-                                  </p:stCondLst>
-                                  <p:childTnLst>
-                                    <p:set>
-                                      <p:cBhvr>
-                                        <p:cTn id="18" dur="1" fill="hold">
-                                          <p:stCondLst>
-                                            <p:cond delay="0"/>
-                                          </p:stCondLst>
-                                        </p:cTn>
-                                        <p:tgtEl>
-                                          <p:spTgt spid="3">
-                                            <p:txEl>
-                                              <p:pRg st="5" end="5"/>
-                                            </p:txEl>
-                                          </p:spTgt>
-                                        </p:tgtEl>
-                                        <p:attrNameLst>
-                                          <p:attrName>style.visibility</p:attrName>
-                                        </p:attrNameLst>
-                                      </p:cBhvr>
-                                      <p:to>
-                                        <p:strVal val="visible"/>
-                                      </p:to>
-                                    </p:set>
-                                  </p:childTnLst>
-                                </p:cTn>
-                              </p:par>
-                              <p:par>
-                                <p:cTn id="19" presetID="1" presetClass="entr" presetSubtype="0" fill="hold" nodeType="withEffect">
-                                  <p:stCondLst>
-                                    <p:cond delay="0"/>
-                                  </p:stCondLst>
-                                  <p:childTnLst>
-                                    <p:set>
-                                      <p:cBhvr>
-                                        <p:cTn id="20" dur="1" fill="hold">
-                                          <p:stCondLst>
-                                            <p:cond delay="0"/>
-                                          </p:stCondLst>
-                                        </p:cTn>
-                                        <p:tgtEl>
-                                          <p:spTgt spid="3">
-                                            <p:txEl>
-                                              <p:pRg st="6" end="6"/>
-                                            </p:txEl>
-                                          </p:spTgt>
-                                        </p:tgtEl>
-                                        <p:attrNameLst>
-                                          <p:attrName>style.visibility</p:attrName>
-                                        </p:attrNameLst>
-                                      </p:cBhvr>
-                                      <p:to>
-                                        <p:strVal val="visible"/>
-                                      </p:to>
-                                    </p:set>
-                                  </p:childTnLst>
-                                </p:cTn>
-                              </p:par>
-                              <p:par>
-                                <p:cTn id="21" presetID="1" presetClass="entr" presetSubtype="0" fill="hold" nodeType="withEffect">
-                                  <p:stCondLst>
-                                    <p:cond delay="0"/>
-                                  </p:stCondLst>
-                                  <p:childTnLst>
-                                    <p:set>
-                                      <p:cBhvr>
-                                        <p:cTn id="22" dur="1" fill="hold">
-                                          <p:stCondLst>
-                                            <p:cond delay="0"/>
-                                          </p:stCondLst>
-                                        </p:cTn>
-                                        <p:tgtEl>
-                                          <p:spTgt spid="3">
-                                            <p:txEl>
-                                              <p:pRg st="7" end="7"/>
-                                            </p:txEl>
-                                          </p:spTgt>
-                                        </p:tgtEl>
-                                        <p:attrNameLst>
-                                          <p:attrName>style.visibility</p:attrName>
-                                        </p:attrNameLst>
-                                      </p:cBhvr>
-                                      <p:to>
-                                        <p:strVal val="visible"/>
-                                      </p:to>
-                                    </p:set>
-                                  </p:childTnLst>
-                                </p:cTn>
-                              </p:par>
-                              <p:par>
-                                <p:cTn id="23" presetID="1" presetClass="entr" presetSubtype="0" fill="hold" nodeType="withEffect">
-                                  <p:stCondLst>
-                                    <p:cond delay="0"/>
-                                  </p:stCondLst>
-                                  <p:childTnLst>
-                                    <p:set>
-                                      <p:cBhvr>
-                                        <p:cTn id="24" dur="1" fill="hold">
-                                          <p:stCondLst>
-                                            <p:cond delay="0"/>
-                                          </p:stCondLst>
-                                        </p:cTn>
-                                        <p:tgtEl>
-                                          <p:spTgt spid="3">
-                                            <p:txEl>
-                                              <p:pRg st="8" end="8"/>
-                                            </p:txEl>
-                                          </p:spTgt>
-                                        </p:tgtEl>
-                                        <p:attrNameLst>
-                                          <p:attrName>style.visibility</p:attrName>
-                                        </p:attrNameLst>
-                                      </p:cBhvr>
-                                      <p:to>
-                                        <p:strVal val="visible"/>
-                                      </p:to>
-                                    </p:set>
-                                  </p:childTnLst>
-                                </p:cTn>
-                              </p:par>
-                            </p:childTnLst>
-                          </p:cTn>
-                        </p:par>
-                      </p:childTnLst>
-                    </p:cTn>
-                  </p:par>
-                  <p:par>
-                    <p:cTn id="25" fill="hold">
-                      <p:stCondLst>
-                        <p:cond delay="indefinite"/>
-                      </p:stCondLst>
-                      <p:childTnLst>
-                        <p:par>
-                          <p:cTn id="26" fill="hold">
-                            <p:stCondLst>
-                              <p:cond delay="0"/>
-                            </p:stCondLst>
-                            <p:childTnLst>
-                              <p:par>
-                                <p:cTn id="27" presetID="1" presetClass="entr" presetSubtype="0" fill="hold" nodeType="clickEffect">
-                                  <p:stCondLst>
-                                    <p:cond delay="0"/>
-                                  </p:stCondLst>
-                                  <p:childTnLst>
-                                    <p:set>
-                                      <p:cBhvr>
-                                        <p:cTn id="28" dur="1" fill="hold">
-                                          <p:stCondLst>
-                                            <p:cond delay="0"/>
-                                          </p:stCondLst>
-                                        </p:cTn>
-                                        <p:tgtEl>
-                                          <p:spTgt spid="3">
-                                            <p:txEl>
-                                              <p:pRg st="9" end="9"/>
-                                            </p:txEl>
-                                          </p:spTgt>
-                                        </p:tgtEl>
-                                        <p:attrNameLst>
-                                          <p:attrName>style.visibility</p:attrName>
-                                        </p:attrNameLst>
-                                      </p:cBhvr>
-                                      <p:to>
-                                        <p:strVal val="visible"/>
-                                      </p:to>
-                                    </p:set>
-                                  </p:childTnLst>
-                                </p:cTn>
-                              </p:par>
-                            </p:childTnLst>
-                          </p:cTn>
-                        </p:par>
-                      </p:childTnLst>
-                    </p:cTn>
-                  </p:par>
-                </p:childTnLst>
-              </p:cTn>
-              <p:prevCondLst>
-                <p:cond evt="onPrev" delay="0">
-                  <p:tgtEl>
-                    <p:sldTgt/>
-                  </p:tgtEl>
-                </p:cond>
-              </p:prevCondLst>
-              <p:nextCondLst>
-                <p:cond evt="onNext" delay="0">
-                  <p:tgtEl>
-                    <p:sldTgt/>
-                  </p:tgtEl>
-                </p:cond>
-              </p:nextCondLst>
-            </p:seq>
-          </p:childTnLst>
-        </p:cTn>
-      </p:par>
-    </p:tnLst>
-  </p:timing>
 </p:sld>
 </file>
 
@@ -17501,6 +17049,648 @@
   <p:cSld>
     <p:spTree>
       <p:nvGrpSpPr>
+        <p:cNvPr id="1" name=""/>
+        <p:cNvGrpSpPr/>
+        <p:nvPr/>
+      </p:nvGrpSpPr>
+      <p:grpSpPr>
+        <a:xfrm>
+          <a:off x="0" y="0"/>
+          <a:ext cx="0" cy="0"/>
+          <a:chOff x="0" y="0"/>
+          <a:chExt cx="0" cy="0"/>
+        </a:xfrm>
+      </p:grpSpPr>
+      <p:sp>
+        <p:nvSpPr>
+          <p:cNvPr id="3" name="Content Placeholder 2">
+            <a:extLst>
+              <a:ext uri="{FF2B5EF4-FFF2-40B4-BE49-F238E27FC236}">
+                <a16:creationId xmlns:a16="http://schemas.microsoft.com/office/drawing/2014/main" id="{258E6AF3-7615-4BD1-878E-A94C93E98F90}"/>
+              </a:ext>
+            </a:extLst>
+          </p:cNvPr>
+          <p:cNvSpPr>
+            <a:spLocks noGrp="1"/>
+          </p:cNvSpPr>
+          <p:nvPr>
+            <p:ph idx="1"/>
+          </p:nvPr>
+        </p:nvSpPr>
+        <p:spPr>
+          <a:xfrm>
+            <a:off x="838200" y="1324927"/>
+            <a:ext cx="10515600" cy="5311004"/>
+          </a:xfrm>
+        </p:spPr>
+        <p:txBody>
+          <a:bodyPr>
+            <a:normAutofit lnSpcReduction="10000"/>
+          </a:bodyPr>
+          <a:lstStyle/>
+          <a:p>
+            <a:pPr marL="0" indent="0">
+              <a:buNone/>
+            </a:pPr>
+            <a:r>
+              <a:rPr lang="en-US" b="1" dirty="0"/>
+              <a:t>Ed Discussion is the primary means of communication </a:t>
+            </a:r>
+            <a:r>
+              <a:rPr lang="en-US" dirty="0"/>
+              <a:t>for this course  </a:t>
+            </a:r>
+          </a:p>
+          <a:p>
+            <a:r>
+              <a:rPr lang="en-US" dirty="0"/>
+              <a:t>Use Ed Discussion to get help with assignments and projects </a:t>
+            </a:r>
+          </a:p>
+          <a:p>
+            <a:pPr lvl="1"/>
+            <a:r>
+              <a:rPr lang="en-US" dirty="0"/>
+              <a:t>It’s </a:t>
+            </a:r>
+            <a:r>
+              <a:rPr lang="en-US" b="1" dirty="0"/>
+              <a:t>okay to post code for your question!</a:t>
+            </a:r>
+          </a:p>
+          <a:p>
+            <a:pPr lvl="1"/>
+            <a:r>
+              <a:rPr lang="en-US" b="1" dirty="0">
+                <a:solidFill>
+                  <a:srgbClr val="C00000"/>
+                </a:solidFill>
+              </a:rPr>
+              <a:t>Post code and complete exception messages if you are dealing with code problem!</a:t>
+            </a:r>
+          </a:p>
+          <a:p>
+            <a:r>
+              <a:rPr lang="en-US" dirty="0"/>
+              <a:t>Graded online class discussions take place in Ed    </a:t>
+            </a:r>
+          </a:p>
+          <a:p>
+            <a:r>
+              <a:rPr lang="en-US" dirty="0"/>
+              <a:t>Private communications regarding matters such as grades</a:t>
+            </a:r>
+          </a:p>
+          <a:p>
+            <a:pPr lvl="1"/>
+            <a:r>
+              <a:rPr lang="en-US" dirty="0"/>
+              <a:t>Use private messages in Ed Discussion for fastest response </a:t>
+            </a:r>
+          </a:p>
+          <a:p>
+            <a:pPr lvl="1"/>
+            <a:r>
+              <a:rPr lang="en-US" dirty="0"/>
+              <a:t>Or, Steve Elston: </a:t>
+            </a:r>
+            <a:r>
+              <a:rPr lang="en-US" dirty="0" err="1"/>
+              <a:t>stephen_elston</a:t>
+            </a:r>
+            <a:r>
+              <a:rPr lang="en-US" dirty="0"/>
+              <a:t> at g dot </a:t>
+            </a:r>
+            <a:r>
+              <a:rPr lang="en-US" dirty="0" err="1"/>
+              <a:t>harvard</a:t>
+            </a:r>
+            <a:r>
+              <a:rPr lang="en-US" dirty="0"/>
+              <a:t> dot </a:t>
+            </a:r>
+            <a:r>
+              <a:rPr lang="en-US" dirty="0" err="1"/>
+              <a:t>edu</a:t>
+            </a:r>
+            <a:r>
+              <a:rPr lang="en-US" dirty="0"/>
+              <a:t>, Hellen Siah Momoh: hem299 at g dot </a:t>
+            </a:r>
+            <a:r>
+              <a:rPr lang="en-US" dirty="0" err="1"/>
+              <a:t>harvard</a:t>
+            </a:r>
+            <a:r>
+              <a:rPr lang="en-US" dirty="0"/>
+              <a:t> </a:t>
+            </a:r>
+            <a:r>
+              <a:rPr lang="en-US" dirty="0" err="1"/>
+              <a:t>dotedu</a:t>
+            </a:r>
+            <a:r>
+              <a:rPr lang="en-US" dirty="0"/>
+              <a:t>, Eric Trucksess: ert713 at g dot </a:t>
+            </a:r>
+            <a:r>
+              <a:rPr lang="en-US" dirty="0" err="1"/>
+              <a:t>harvard</a:t>
+            </a:r>
+            <a:r>
+              <a:rPr lang="en-US" dirty="0"/>
+              <a:t> dot </a:t>
+            </a:r>
+            <a:r>
+              <a:rPr lang="en-US" dirty="0" err="1"/>
+              <a:t>edu</a:t>
+            </a:r>
+            <a:endParaRPr lang="en-US" b="0" i="0" dirty="0">
+              <a:effectLst/>
+              <a:latin typeface="Google Sans"/>
+            </a:endParaRPr>
+          </a:p>
+          <a:p>
+            <a:pPr lvl="1"/>
+            <a:r>
+              <a:rPr lang="en-US" b="1" dirty="0">
+                <a:latin typeface="Google Sans"/>
+              </a:rPr>
+              <a:t>Private one-on-one appointments on request</a:t>
+            </a:r>
+            <a:endParaRPr lang="en-US" b="1" i="0" dirty="0">
+              <a:effectLst/>
+              <a:latin typeface="Google Sans"/>
+            </a:endParaRPr>
+          </a:p>
+          <a:p>
+            <a:r>
+              <a:rPr lang="en-US" b="1" dirty="0">
+                <a:solidFill>
+                  <a:srgbClr val="C00000"/>
+                </a:solidFill>
+              </a:rPr>
+              <a:t>Do not use Canvas messages, unless you want a delayed response!   </a:t>
+            </a:r>
+          </a:p>
+        </p:txBody>
+      </p:sp>
+      <p:sp>
+        <p:nvSpPr>
+          <p:cNvPr id="6" name="Title 1">
+            <a:extLst>
+              <a:ext uri="{FF2B5EF4-FFF2-40B4-BE49-F238E27FC236}">
+                <a16:creationId xmlns:a16="http://schemas.microsoft.com/office/drawing/2014/main" id="{CD29F70F-B868-451B-A65D-8721F4C7A2D9}"/>
+              </a:ext>
+            </a:extLst>
+          </p:cNvPr>
+          <p:cNvSpPr txBox="1">
+            <a:spLocks/>
+          </p:cNvSpPr>
+          <p:nvPr/>
+        </p:nvSpPr>
+        <p:spPr>
+          <a:xfrm>
+            <a:off x="838200" y="-635"/>
+            <a:ext cx="10515600" cy="1325563"/>
+          </a:xfrm>
+          <a:prstGeom prst="rect">
+            <a:avLst/>
+          </a:prstGeom>
+        </p:spPr>
+        <p:txBody>
+          <a:bodyPr vert="horz" lIns="91440" tIns="45720" rIns="91440" bIns="45720" rtlCol="0" anchor="ctr">
+            <a:normAutofit/>
+          </a:bodyPr>
+          <a:lstStyle>
+            <a:lvl1pPr algn="l" defTabSz="914400" rtl="0" eaLnBrk="1" latinLnBrk="0" hangingPunct="1">
+              <a:lnSpc>
+                <a:spcPct val="90000"/>
+              </a:lnSpc>
+              <a:spcBef>
+                <a:spcPct val="0"/>
+              </a:spcBef>
+              <a:buNone/>
+              <a:defRPr sz="4400" kern="1200">
+                <a:solidFill>
+                  <a:schemeClr val="tx1"/>
+                </a:solidFill>
+                <a:latin typeface="+mj-lt"/>
+                <a:ea typeface="+mj-ea"/>
+                <a:cs typeface="+mj-cs"/>
+              </a:defRPr>
+            </a:lvl1pPr>
+          </a:lstStyle>
+          <a:p>
+            <a:r>
+              <a:rPr lang="en-US" dirty="0">
+                <a:latin typeface="+mn-lt"/>
+              </a:rPr>
+              <a:t>Communication </a:t>
+            </a:r>
+          </a:p>
+        </p:txBody>
+      </p:sp>
+    </p:spTree>
+    <p:extLst>
+      <p:ext uri="{BB962C8B-B14F-4D97-AF65-F5344CB8AC3E}">
+        <p14:creationId xmlns:p14="http://schemas.microsoft.com/office/powerpoint/2010/main" val="1228520043"/>
+      </p:ext>
+    </p:extLst>
+  </p:cSld>
+  <p:clrMapOvr>
+    <a:masterClrMapping/>
+  </p:clrMapOvr>
+  <p:timing>
+    <p:tnLst>
+      <p:par>
+        <p:cTn id="1" dur="indefinite" restart="never" nodeType="tmRoot">
+          <p:childTnLst>
+            <p:seq concurrent="1" nextAc="seek">
+              <p:cTn id="2" dur="indefinite" nodeType="mainSeq">
+                <p:childTnLst>
+                  <p:par>
+                    <p:cTn id="3" fill="hold">
+                      <p:stCondLst>
+                        <p:cond delay="indefinite"/>
+                      </p:stCondLst>
+                      <p:childTnLst>
+                        <p:par>
+                          <p:cTn id="4" fill="hold">
+                            <p:stCondLst>
+                              <p:cond delay="0"/>
+                            </p:stCondLst>
+                            <p:childTnLst>
+                              <p:par>
+                                <p:cTn id="5" presetID="1" presetClass="entr" presetSubtype="0" fill="hold" nodeType="clickEffect">
+                                  <p:stCondLst>
+                                    <p:cond delay="0"/>
+                                  </p:stCondLst>
+                                  <p:childTnLst>
+                                    <p:set>
+                                      <p:cBhvr>
+                                        <p:cTn id="6" dur="1" fill="hold">
+                                          <p:stCondLst>
+                                            <p:cond delay="0"/>
+                                          </p:stCondLst>
+                                        </p:cTn>
+                                        <p:tgtEl>
+                                          <p:spTgt spid="3">
+                                            <p:txEl>
+                                              <p:pRg st="1" end="1"/>
+                                            </p:txEl>
+                                          </p:spTgt>
+                                        </p:tgtEl>
+                                        <p:attrNameLst>
+                                          <p:attrName>style.visibility</p:attrName>
+                                        </p:attrNameLst>
+                                      </p:cBhvr>
+                                      <p:to>
+                                        <p:strVal val="visible"/>
+                                      </p:to>
+                                    </p:set>
+                                  </p:childTnLst>
+                                </p:cTn>
+                              </p:par>
+                              <p:par>
+                                <p:cTn id="7" presetID="1" presetClass="entr" presetSubtype="0" fill="hold" nodeType="withEffect">
+                                  <p:stCondLst>
+                                    <p:cond delay="0"/>
+                                  </p:stCondLst>
+                                  <p:childTnLst>
+                                    <p:set>
+                                      <p:cBhvr>
+                                        <p:cTn id="8" dur="1" fill="hold">
+                                          <p:stCondLst>
+                                            <p:cond delay="0"/>
+                                          </p:stCondLst>
+                                        </p:cTn>
+                                        <p:tgtEl>
+                                          <p:spTgt spid="3">
+                                            <p:txEl>
+                                              <p:pRg st="2" end="2"/>
+                                            </p:txEl>
+                                          </p:spTgt>
+                                        </p:tgtEl>
+                                        <p:attrNameLst>
+                                          <p:attrName>style.visibility</p:attrName>
+                                        </p:attrNameLst>
+                                      </p:cBhvr>
+                                      <p:to>
+                                        <p:strVal val="visible"/>
+                                      </p:to>
+                                    </p:set>
+                                  </p:childTnLst>
+                                </p:cTn>
+                              </p:par>
+                              <p:par>
+                                <p:cTn id="9" presetID="1" presetClass="entr" presetSubtype="0" fill="hold" nodeType="withEffect">
+                                  <p:stCondLst>
+                                    <p:cond delay="0"/>
+                                  </p:stCondLst>
+                                  <p:childTnLst>
+                                    <p:set>
+                                      <p:cBhvr>
+                                        <p:cTn id="10" dur="1" fill="hold">
+                                          <p:stCondLst>
+                                            <p:cond delay="0"/>
+                                          </p:stCondLst>
+                                        </p:cTn>
+                                        <p:tgtEl>
+                                          <p:spTgt spid="3">
+                                            <p:txEl>
+                                              <p:pRg st="3" end="3"/>
+                                            </p:txEl>
+                                          </p:spTgt>
+                                        </p:tgtEl>
+                                        <p:attrNameLst>
+                                          <p:attrName>style.visibility</p:attrName>
+                                        </p:attrNameLst>
+                                      </p:cBhvr>
+                                      <p:to>
+                                        <p:strVal val="visible"/>
+                                      </p:to>
+                                    </p:set>
+                                  </p:childTnLst>
+                                </p:cTn>
+                              </p:par>
+                            </p:childTnLst>
+                          </p:cTn>
+                        </p:par>
+                      </p:childTnLst>
+                    </p:cTn>
+                  </p:par>
+                  <p:par>
+                    <p:cTn id="11" fill="hold">
+                      <p:stCondLst>
+                        <p:cond delay="indefinite"/>
+                      </p:stCondLst>
+                      <p:childTnLst>
+                        <p:par>
+                          <p:cTn id="12" fill="hold">
+                            <p:stCondLst>
+                              <p:cond delay="0"/>
+                            </p:stCondLst>
+                            <p:childTnLst>
+                              <p:par>
+                                <p:cTn id="13" presetID="1" presetClass="entr" presetSubtype="0" fill="hold" nodeType="clickEffect">
+                                  <p:stCondLst>
+                                    <p:cond delay="0"/>
+                                  </p:stCondLst>
+                                  <p:childTnLst>
+                                    <p:set>
+                                      <p:cBhvr>
+                                        <p:cTn id="14" dur="1" fill="hold">
+                                          <p:stCondLst>
+                                            <p:cond delay="0"/>
+                                          </p:stCondLst>
+                                        </p:cTn>
+                                        <p:tgtEl>
+                                          <p:spTgt spid="3">
+                                            <p:txEl>
+                                              <p:pRg st="4" end="4"/>
+                                            </p:txEl>
+                                          </p:spTgt>
+                                        </p:tgtEl>
+                                        <p:attrNameLst>
+                                          <p:attrName>style.visibility</p:attrName>
+                                        </p:attrNameLst>
+                                      </p:cBhvr>
+                                      <p:to>
+                                        <p:strVal val="visible"/>
+                                      </p:to>
+                                    </p:set>
+                                  </p:childTnLst>
+                                </p:cTn>
+                              </p:par>
+                            </p:childTnLst>
+                          </p:cTn>
+                        </p:par>
+                      </p:childTnLst>
+                    </p:cTn>
+                  </p:par>
+                  <p:par>
+                    <p:cTn id="15" fill="hold">
+                      <p:stCondLst>
+                        <p:cond delay="indefinite"/>
+                      </p:stCondLst>
+                      <p:childTnLst>
+                        <p:par>
+                          <p:cTn id="16" fill="hold">
+                            <p:stCondLst>
+                              <p:cond delay="0"/>
+                            </p:stCondLst>
+                            <p:childTnLst>
+                              <p:par>
+                                <p:cTn id="17" presetID="1" presetClass="entr" presetSubtype="0" fill="hold" nodeType="clickEffect">
+                                  <p:stCondLst>
+                                    <p:cond delay="0"/>
+                                  </p:stCondLst>
+                                  <p:childTnLst>
+                                    <p:set>
+                                      <p:cBhvr>
+                                        <p:cTn id="18" dur="1" fill="hold">
+                                          <p:stCondLst>
+                                            <p:cond delay="0"/>
+                                          </p:stCondLst>
+                                        </p:cTn>
+                                        <p:tgtEl>
+                                          <p:spTgt spid="3">
+                                            <p:txEl>
+                                              <p:pRg st="5" end="5"/>
+                                            </p:txEl>
+                                          </p:spTgt>
+                                        </p:tgtEl>
+                                        <p:attrNameLst>
+                                          <p:attrName>style.visibility</p:attrName>
+                                        </p:attrNameLst>
+                                      </p:cBhvr>
+                                      <p:to>
+                                        <p:strVal val="visible"/>
+                                      </p:to>
+                                    </p:set>
+                                  </p:childTnLst>
+                                </p:cTn>
+                              </p:par>
+                              <p:par>
+                                <p:cTn id="19" presetID="1" presetClass="entr" presetSubtype="0" fill="hold" nodeType="withEffect">
+                                  <p:stCondLst>
+                                    <p:cond delay="0"/>
+                                  </p:stCondLst>
+                                  <p:childTnLst>
+                                    <p:set>
+                                      <p:cBhvr>
+                                        <p:cTn id="20" dur="1" fill="hold">
+                                          <p:stCondLst>
+                                            <p:cond delay="0"/>
+                                          </p:stCondLst>
+                                        </p:cTn>
+                                        <p:tgtEl>
+                                          <p:spTgt spid="3">
+                                            <p:txEl>
+                                              <p:pRg st="6" end="6"/>
+                                            </p:txEl>
+                                          </p:spTgt>
+                                        </p:tgtEl>
+                                        <p:attrNameLst>
+                                          <p:attrName>style.visibility</p:attrName>
+                                        </p:attrNameLst>
+                                      </p:cBhvr>
+                                      <p:to>
+                                        <p:strVal val="visible"/>
+                                      </p:to>
+                                    </p:set>
+                                  </p:childTnLst>
+                                </p:cTn>
+                              </p:par>
+                              <p:par>
+                                <p:cTn id="21" presetID="1" presetClass="entr" presetSubtype="0" fill="hold" nodeType="withEffect">
+                                  <p:stCondLst>
+                                    <p:cond delay="0"/>
+                                  </p:stCondLst>
+                                  <p:childTnLst>
+                                    <p:set>
+                                      <p:cBhvr>
+                                        <p:cTn id="22" dur="1" fill="hold">
+                                          <p:stCondLst>
+                                            <p:cond delay="0"/>
+                                          </p:stCondLst>
+                                        </p:cTn>
+                                        <p:tgtEl>
+                                          <p:spTgt spid="3">
+                                            <p:txEl>
+                                              <p:pRg st="7" end="7"/>
+                                            </p:txEl>
+                                          </p:spTgt>
+                                        </p:tgtEl>
+                                        <p:attrNameLst>
+                                          <p:attrName>style.visibility</p:attrName>
+                                        </p:attrNameLst>
+                                      </p:cBhvr>
+                                      <p:to>
+                                        <p:strVal val="visible"/>
+                                      </p:to>
+                                    </p:set>
+                                  </p:childTnLst>
+                                </p:cTn>
+                              </p:par>
+                              <p:par>
+                                <p:cTn id="23" presetID="1" presetClass="entr" presetSubtype="0" fill="hold" nodeType="withEffect">
+                                  <p:stCondLst>
+                                    <p:cond delay="0"/>
+                                  </p:stCondLst>
+                                  <p:childTnLst>
+                                    <p:set>
+                                      <p:cBhvr>
+                                        <p:cTn id="24" dur="1" fill="hold">
+                                          <p:stCondLst>
+                                            <p:cond delay="0"/>
+                                          </p:stCondLst>
+                                        </p:cTn>
+                                        <p:tgtEl>
+                                          <p:spTgt spid="3">
+                                            <p:txEl>
+                                              <p:pRg st="8" end="8"/>
+                                            </p:txEl>
+                                          </p:spTgt>
+                                        </p:tgtEl>
+                                        <p:attrNameLst>
+                                          <p:attrName>style.visibility</p:attrName>
+                                        </p:attrNameLst>
+                                      </p:cBhvr>
+                                      <p:to>
+                                        <p:strVal val="visible"/>
+                                      </p:to>
+                                    </p:set>
+                                  </p:childTnLst>
+                                </p:cTn>
+                              </p:par>
+                            </p:childTnLst>
+                          </p:cTn>
+                        </p:par>
+                      </p:childTnLst>
+                    </p:cTn>
+                  </p:par>
+                  <p:par>
+                    <p:cTn id="25" fill="hold">
+                      <p:stCondLst>
+                        <p:cond delay="indefinite"/>
+                      </p:stCondLst>
+                      <p:childTnLst>
+                        <p:par>
+                          <p:cTn id="26" fill="hold">
+                            <p:stCondLst>
+                              <p:cond delay="0"/>
+                            </p:stCondLst>
+                            <p:childTnLst>
+                              <p:par>
+                                <p:cTn id="27" presetID="1" presetClass="entr" presetSubtype="0" fill="hold" nodeType="clickEffect">
+                                  <p:stCondLst>
+                                    <p:cond delay="0"/>
+                                  </p:stCondLst>
+                                  <p:childTnLst>
+                                    <p:set>
+                                      <p:cBhvr>
+                                        <p:cTn id="28" dur="1" fill="hold">
+                                          <p:stCondLst>
+                                            <p:cond delay="0"/>
+                                          </p:stCondLst>
+                                        </p:cTn>
+                                        <p:tgtEl>
+                                          <p:spTgt spid="3">
+                                            <p:txEl>
+                                              <p:pRg st="9" end="9"/>
+                                            </p:txEl>
+                                          </p:spTgt>
+                                        </p:tgtEl>
+                                        <p:attrNameLst>
+                                          <p:attrName>style.visibility</p:attrName>
+                                        </p:attrNameLst>
+                                      </p:cBhvr>
+                                      <p:to>
+                                        <p:strVal val="visible"/>
+                                      </p:to>
+                                    </p:set>
+                                  </p:childTnLst>
+                                </p:cTn>
+                              </p:par>
+                            </p:childTnLst>
+                          </p:cTn>
+                        </p:par>
+                      </p:childTnLst>
+                    </p:cTn>
+                  </p:par>
+                </p:childTnLst>
+              </p:cTn>
+              <p:prevCondLst>
+                <p:cond evt="onPrev" delay="0">
+                  <p:tgtEl>
+                    <p:sldTgt/>
+                  </p:tgtEl>
+                </p:cond>
+              </p:prevCondLst>
+              <p:nextCondLst>
+                <p:cond evt="onNext" delay="0">
+                  <p:tgtEl>
+                    <p:sldTgt/>
+                  </p:tgtEl>
+                </p:cond>
+              </p:nextCondLst>
+            </p:seq>
+          </p:childTnLst>
+        </p:cTn>
+      </p:par>
+    </p:tnLst>
+  </p:timing>
+</p:sld>
+</file>
+
+<file path=ppt/slides/slide31.xml><?xml version="1.0" encoding="utf-8"?>
+<p:sld xmlns:a="http://schemas.openxmlformats.org/drawingml/2006/main" xmlns:r="http://schemas.openxmlformats.org/officeDocument/2006/relationships" xmlns:p="http://schemas.openxmlformats.org/presentationml/2006/main">
+  <p:cSld>
+    <p:spTree>
+      <p:nvGrpSpPr>
         <p:cNvPr id="1" name="">
           <a:extLst>
             <a:ext uri="{FF2B5EF4-FFF2-40B4-BE49-F238E27FC236}">
@@ -17975,7 +18165,7 @@
 </p:sld>
 </file>
 
-<file path=ppt/slides/slide31.xml><?xml version="1.0" encoding="utf-8"?>
+<file path=ppt/slides/slide32.xml><?xml version="1.0" encoding="utf-8"?>
 <p:sld xmlns:a="http://schemas.openxmlformats.org/drawingml/2006/main" xmlns:r="http://schemas.openxmlformats.org/officeDocument/2006/relationships" xmlns:p="http://schemas.openxmlformats.org/presentationml/2006/main">
   <p:cSld>
     <p:spTree>
@@ -18081,12 +18271,43 @@
           <a:p>
             <a:pPr lvl="0"/>
             <a:r>
-              <a:rPr lang="en-US" b="1" dirty="0"/>
+              <a:rPr lang="en-US" b="1" dirty="0">
+                <a:solidFill>
+                  <a:srgbClr val="C00000"/>
+                </a:solidFill>
+              </a:rPr>
               <a:t>Attribution &amp; Integrity:</a:t>
             </a:r>
             <a:r>
-              <a:rPr lang="en-US" dirty="0"/>
-              <a:t> Cite AI use per the Harvard Academic Integrity Policy</a:t>
+              <a:rPr lang="en-US" dirty="0">
+                <a:solidFill>
+                  <a:srgbClr val="C00000"/>
+                </a:solidFill>
+              </a:rPr>
+              <a:t> Cite AI use per the </a:t>
+            </a:r>
+            <a:r>
+              <a:rPr lang="en-US" dirty="0">
+                <a:solidFill>
+                  <a:srgbClr val="C00000"/>
+                </a:solidFill>
+                <a:hlinkClick r:id="rId2">
+                  <a:extLst>
+                    <a:ext uri="{A12FA001-AC4F-418D-AE19-62706E023703}">
+                      <ahyp:hlinkClr xmlns:ahyp="http://schemas.microsoft.com/office/drawing/2018/hyperlinkcolor" val="tx"/>
+                    </a:ext>
+                  </a:extLst>
+                </a:hlinkClick>
+              </a:rPr>
+              <a:t>Harvard Extension School Academic Integrity Policy</a:t>
+            </a:r>
+            <a:r>
+              <a:rPr lang="en-US" dirty="0">
+                <a:solidFill>
+                  <a:srgbClr val="C00000"/>
+                </a:solidFill>
+              </a:rPr>
+              <a:t>!</a:t>
             </a:r>
           </a:p>
           <a:p>
@@ -18491,185 +18712,6 @@
 </p:sld>
 </file>
 
-<file path=ppt/slides/slide32.xml><?xml version="1.0" encoding="utf-8"?>
-<p:sld xmlns:a="http://schemas.openxmlformats.org/drawingml/2006/main" xmlns:r="http://schemas.openxmlformats.org/officeDocument/2006/relationships" xmlns:p="http://schemas.openxmlformats.org/presentationml/2006/main" show="0">
-  <p:cSld>
-    <p:spTree>
-      <p:nvGrpSpPr>
-        <p:cNvPr id="1" name=""/>
-        <p:cNvGrpSpPr/>
-        <p:nvPr/>
-      </p:nvGrpSpPr>
-      <p:grpSpPr>
-        <a:xfrm>
-          <a:off x="0" y="0"/>
-          <a:ext cx="0" cy="0"/>
-          <a:chOff x="0" y="0"/>
-          <a:chExt cx="0" cy="0"/>
-        </a:xfrm>
-      </p:grpSpPr>
-      <p:sp>
-        <p:nvSpPr>
-          <p:cNvPr id="3" name="Content Placeholder 2">
-            <a:extLst>
-              <a:ext uri="{FF2B5EF4-FFF2-40B4-BE49-F238E27FC236}">
-                <a16:creationId xmlns:a16="http://schemas.microsoft.com/office/drawing/2014/main" id="{258E6AF3-7615-4BD1-878E-A94C93E98F90}"/>
-              </a:ext>
-            </a:extLst>
-          </p:cNvPr>
-          <p:cNvSpPr>
-            <a:spLocks noGrp="1"/>
-          </p:cNvSpPr>
-          <p:nvPr>
-            <p:ph idx="1"/>
-          </p:nvPr>
-        </p:nvSpPr>
-        <p:spPr>
-          <a:xfrm>
-            <a:off x="838200" y="1324927"/>
-            <a:ext cx="10515600" cy="4898217"/>
-          </a:xfrm>
-        </p:spPr>
-        <p:txBody>
-          <a:bodyPr>
-            <a:normAutofit/>
-          </a:bodyPr>
-          <a:lstStyle/>
-          <a:p>
-            <a:pPr marL="0" indent="0">
-              <a:buNone/>
-            </a:pPr>
-            <a:r>
-              <a:rPr lang="en-US" dirty="0"/>
-              <a:t>Timely release of assignment solutions is an important part of the learning process </a:t>
-            </a:r>
-          </a:p>
-          <a:p>
-            <a:r>
-              <a:rPr lang="en-US" b="1" dirty="0"/>
-              <a:t>Do not fall behind! </a:t>
-            </a:r>
-            <a:r>
-              <a:rPr lang="en-US" dirty="0"/>
-              <a:t>With 9-10 assignments and a project, there is very </a:t>
-            </a:r>
-            <a:r>
-              <a:rPr lang="en-US" b="1" dirty="0"/>
-              <a:t>little time to “catch-up”</a:t>
-            </a:r>
-            <a:endParaRPr lang="en-US" dirty="0"/>
-          </a:p>
-          <a:p>
-            <a:r>
-              <a:rPr lang="en-US" dirty="0"/>
-              <a:t>Late assignment policy:   </a:t>
-            </a:r>
-          </a:p>
-          <a:p>
-            <a:pPr lvl="1"/>
-            <a:r>
-              <a:rPr lang="en-US" dirty="0"/>
-              <a:t>Up to one day late - no penalty  </a:t>
-            </a:r>
-          </a:p>
-          <a:p>
-            <a:pPr lvl="1"/>
-            <a:r>
-              <a:rPr lang="en-US" dirty="0"/>
-              <a:t>Up to 6 days late - less 20% </a:t>
-            </a:r>
-          </a:p>
-          <a:p>
-            <a:pPr lvl="1"/>
-            <a:r>
-              <a:rPr lang="en-US" dirty="0"/>
-              <a:t>More than 6 days late - no credit   </a:t>
-            </a:r>
-          </a:p>
-          <a:p>
-            <a:pPr marL="0" indent="0">
-              <a:buNone/>
-            </a:pPr>
-            <a:r>
-              <a:rPr lang="en-US" b="1" dirty="0">
-                <a:solidFill>
-                  <a:srgbClr val="C00000"/>
-                </a:solidFill>
-              </a:rPr>
-              <a:t>Make sure you turn in work on time!</a:t>
-            </a:r>
-          </a:p>
-        </p:txBody>
-      </p:sp>
-      <p:sp>
-        <p:nvSpPr>
-          <p:cNvPr id="6" name="Title 1">
-            <a:extLst>
-              <a:ext uri="{FF2B5EF4-FFF2-40B4-BE49-F238E27FC236}">
-                <a16:creationId xmlns:a16="http://schemas.microsoft.com/office/drawing/2014/main" id="{CD29F70F-B868-451B-A65D-8721F4C7A2D9}"/>
-              </a:ext>
-            </a:extLst>
-          </p:cNvPr>
-          <p:cNvSpPr txBox="1">
-            <a:spLocks/>
-          </p:cNvSpPr>
-          <p:nvPr/>
-        </p:nvSpPr>
-        <p:spPr>
-          <a:xfrm>
-            <a:off x="838200" y="-635"/>
-            <a:ext cx="10515600" cy="1325563"/>
-          </a:xfrm>
-          <a:prstGeom prst="rect">
-            <a:avLst/>
-          </a:prstGeom>
-        </p:spPr>
-        <p:txBody>
-          <a:bodyPr vert="horz" lIns="91440" tIns="45720" rIns="91440" bIns="45720" rtlCol="0" anchor="ctr">
-            <a:normAutofit/>
-          </a:bodyPr>
-          <a:lstStyle>
-            <a:lvl1pPr algn="l" defTabSz="914400" rtl="0" eaLnBrk="1" latinLnBrk="0" hangingPunct="1">
-              <a:lnSpc>
-                <a:spcPct val="90000"/>
-              </a:lnSpc>
-              <a:spcBef>
-                <a:spcPct val="0"/>
-              </a:spcBef>
-              <a:buNone/>
-              <a:defRPr sz="4400" kern="1200">
-                <a:solidFill>
-                  <a:schemeClr val="tx1"/>
-                </a:solidFill>
-                <a:latin typeface="+mj-lt"/>
-                <a:ea typeface="+mj-ea"/>
-                <a:cs typeface="+mj-cs"/>
-              </a:defRPr>
-            </a:lvl1pPr>
-          </a:lstStyle>
-          <a:p>
-            <a:r>
-              <a:rPr lang="en-US" dirty="0">
-                <a:latin typeface="+mn-lt"/>
-              </a:rPr>
-              <a:t>Late Assignment Policy – For regular semester</a:t>
-            </a:r>
-          </a:p>
-        </p:txBody>
-      </p:sp>
-    </p:spTree>
-    <p:extLst>
-      <p:ext uri="{BB962C8B-B14F-4D97-AF65-F5344CB8AC3E}">
-        <p14:creationId xmlns:p14="http://schemas.microsoft.com/office/powerpoint/2010/main" val="1424932590"/>
-      </p:ext>
-    </p:extLst>
-  </p:cSld>
-  <p:clrMapOvr>
-    <a:masterClrMapping/>
-  </p:clrMapOvr>
-</p:sld>
-</file>
-
 <file path=ppt/slides/slide33.xml><?xml version="1.0" encoding="utf-8"?>
 <p:sld xmlns:a="http://schemas.openxmlformats.org/drawingml/2006/main" xmlns:r="http://schemas.openxmlformats.org/officeDocument/2006/relationships" xmlns:p="http://schemas.openxmlformats.org/presentationml/2006/main">
   <p:cSld>
@@ -20330,8 +20372,8 @@
           <a:chExt cx="0" cy="0"/>
         </a:xfrm>
       </p:grpSpPr>
-      <mc:AlternateContent xmlns:mc="http://schemas.openxmlformats.org/markup-compatibility/2006">
-        <mc:Choice xmlns:a14="http://schemas.microsoft.com/office/drawing/2010/main" Requires="a14">
+      <mc:AlternateContent xmlns:mc="http://schemas.openxmlformats.org/markup-compatibility/2006" xmlns:a14="http://schemas.microsoft.com/office/drawing/2010/main">
+        <mc:Choice Requires="a14">
           <p:sp>
             <p:nvSpPr>
               <p:cNvPr id="3" name="Content Placeholder 2">
@@ -20486,7 +20528,7 @@
             </p:txBody>
           </p:sp>
         </mc:Choice>
-        <mc:Fallback>
+        <mc:Fallback xmlns="">
           <p:sp>
             <p:nvSpPr>
               <p:cNvPr id="3" name="Content Placeholder 2">
@@ -23700,8 +23742,8 @@
           <a:chExt cx="0" cy="0"/>
         </a:xfrm>
       </p:grpSpPr>
-      <mc:AlternateContent xmlns:mc="http://schemas.openxmlformats.org/markup-compatibility/2006" xmlns:a14="http://schemas.microsoft.com/office/drawing/2010/main">
-        <mc:Choice Requires="a14">
+      <mc:AlternateContent xmlns:mc="http://schemas.openxmlformats.org/markup-compatibility/2006">
+        <mc:Choice xmlns:a14="http://schemas.microsoft.com/office/drawing/2010/main" Requires="a14">
           <p:sp>
             <p:nvSpPr>
               <p:cNvPr id="3" name="Content Placeholder 2">
@@ -23795,7 +23837,7 @@
                       <a:rPr lang="en-US" b="0" i="1" smtClean="0">
                         <a:latin typeface="Cambria Math" panose="02040503050406030204" pitchFamily="18" charset="0"/>
                       </a:rPr>
-                      <m:t>h</m:t>
+                      <m:t>ℎ</m:t>
                     </m:r>
                     <m:r>
                       <a:rPr lang="en-US" b="0" i="1" smtClean="0">
@@ -23895,16 +23937,12 @@
               <a:p>
                 <a:pPr lvl="1"/>
                 <a:r>
-                  <a:rPr lang="en-US" b="1"/>
-                  <a:t>Hashed </a:t>
-                </a:r>
-                <a:r>
                   <a:rPr lang="en-US" b="1" dirty="0"/>
-                  <a:t>key-value pairs </a:t>
+                  <a:t>Hashed key-value pairs </a:t>
                 </a:r>
                 <a:r>
                   <a:rPr lang="en-US" dirty="0"/>
-                  <a:t>as a tuple, </a:t>
+                  <a:t>form tuple, </a:t>
                 </a:r>
                 <a14:m>
                   <m:oMath xmlns:m="http://schemas.openxmlformats.org/officeDocument/2006/math">
@@ -23918,7 +23956,7 @@
                       <a:rPr lang="en-US" i="1">
                         <a:latin typeface="Cambria Math" panose="02040503050406030204" pitchFamily="18" charset="0"/>
                       </a:rPr>
-                      <m:t>h</m:t>
+                      <m:t>ℎ</m:t>
                     </m:r>
                     <m:r>
                       <a:rPr lang="en-US" i="1">
@@ -23958,7 +23996,7 @@
             </p:txBody>
           </p:sp>
         </mc:Choice>
-        <mc:Fallback xmlns="">
+        <mc:Fallback>
           <p:sp>
             <p:nvSpPr>
               <p:cNvPr id="3" name="Content Placeholder 2">
@@ -24372,8 +24410,8 @@
           </a:p>
         </p:txBody>
       </p:sp>
-      <mc:AlternateContent xmlns:mc="http://schemas.openxmlformats.org/markup-compatibility/2006">
-        <mc:Choice xmlns:a14="http://schemas.microsoft.com/office/drawing/2010/main" Requires="a14">
+      <mc:AlternateContent xmlns:mc="http://schemas.openxmlformats.org/markup-compatibility/2006" xmlns:a14="http://schemas.microsoft.com/office/drawing/2010/main">
+        <mc:Choice Requires="a14">
           <p:graphicFrame>
             <p:nvGraphicFramePr>
               <p:cNvPr id="2" name="Table 3">
@@ -24620,16 +24658,7 @@
                                   </a:solidFill>
                                   <a:latin typeface="Cambria Math" panose="02040503050406030204" pitchFamily="18" charset="0"/>
                                 </a:rPr>
-                                <m:t>(</m:t>
-                              </m:r>
-                              <m:r>
-                                <a:rPr lang="en-US" sz="2400" b="0" i="0" smtClean="0">
-                                  <a:solidFill>
-                                    <a:schemeClr val="tx1"/>
-                                  </a:solidFill>
-                                  <a:latin typeface="Cambria Math" panose="02040503050406030204" pitchFamily="18" charset="0"/>
-                                </a:rPr>
-                                <m:t>1</m:t>
+                                <m:t>(1</m:t>
                               </m:r>
                             </m:oMath>
                           </a14:m>
@@ -24781,10 +24810,7 @@
                           <a:pPr algn="ctr"/>
                           <a14:m>
                             <m:oMathPara xmlns:m="http://schemas.openxmlformats.org/officeDocument/2006/math">
-                              <m:oMathParaPr>
-                                <m:jc m:val="centerGroup"/>
-                              </m:oMathParaPr>
-                              <m:oMath xmlns:m="http://schemas.openxmlformats.org/officeDocument/2006/math">
+                              <m:oMath>
                                 <m:r>
                                   <a:rPr lang="en-US" sz="2400" b="0" i="1" smtClean="0">
                                     <a:solidFill>
@@ -24806,7 +24832,7 @@
                                 <m:func>
                                   <m:funcPr>
                                     <m:ctrlPr>
-                                      <a:rPr lang="en-US" sz="2400" b="0" i="1" smtClean="0">
+                                      <a:rPr lang="en-US" sz="2400" b="0" i="0" smtClean="0">
                                         <a:solidFill>
                                           <a:schemeClr val="tx1"/>
                                         </a:solidFill>
@@ -24869,10 +24895,7 @@
                           <a:pPr algn="ctr"/>
                           <a14:m>
                             <m:oMathPara xmlns:m="http://schemas.openxmlformats.org/officeDocument/2006/math">
-                              <m:oMathParaPr>
-                                <m:jc m:val="centerGroup"/>
-                              </m:oMathParaPr>
-                              <m:oMath xmlns:m="http://schemas.openxmlformats.org/officeDocument/2006/math">
+                              <m:oMath>
                                 <m:r>
                                   <a:rPr lang="en-US" sz="2400" b="0" i="1" smtClean="0">
                                     <a:solidFill>
@@ -24929,10 +24952,7 @@
                           <a:pPr algn="ctr"/>
                           <a14:m>
                             <m:oMathPara xmlns:m="http://schemas.openxmlformats.org/officeDocument/2006/math">
-                              <m:oMathParaPr>
-                                <m:jc m:val="centerGroup"/>
-                              </m:oMathParaPr>
-                              <m:oMath xmlns:m="http://schemas.openxmlformats.org/officeDocument/2006/math">
+                              <m:oMath>
                                 <m:r>
                                   <a:rPr lang="en-US" sz="2400" b="0" i="1" smtClean="0">
                                     <a:solidFill>
@@ -24989,10 +25009,7 @@
                           <a:pPr algn="ctr"/>
                           <a14:m>
                             <m:oMathPara xmlns:m="http://schemas.openxmlformats.org/officeDocument/2006/math">
-                              <m:oMathParaPr>
-                                <m:jc m:val="centerGroup"/>
-                              </m:oMathParaPr>
-                              <m:oMath xmlns:m="http://schemas.openxmlformats.org/officeDocument/2006/math">
+                              <m:oMath>
                                 <m:r>
                                   <a:rPr lang="en-US" sz="2400" b="0" i="1" smtClean="0">
                                     <a:solidFill>
@@ -25143,16 +25160,7 @@
                                   </a:solidFill>
                                   <a:latin typeface="Cambria Math" panose="02040503050406030204" pitchFamily="18" charset="0"/>
                                 </a:rPr>
-                                <m:t>(</m:t>
-                              </m:r>
-                              <m:r>
-                                <a:rPr lang="en-US" sz="2400" b="0" i="0" smtClean="0">
-                                  <a:solidFill>
-                                    <a:schemeClr val="tx1"/>
-                                  </a:solidFill>
-                                  <a:latin typeface="Cambria Math" panose="02040503050406030204" pitchFamily="18" charset="0"/>
-                                </a:rPr>
-                                <m:t>1</m:t>
+                                <m:t>(1</m:t>
                               </m:r>
                             </m:oMath>
                           </a14:m>
@@ -25208,16 +25216,7 @@
                                   </a:solidFill>
                                   <a:latin typeface="Cambria Math" panose="02040503050406030204" pitchFamily="18" charset="0"/>
                                 </a:rPr>
-                                <m:t>(</m:t>
-                              </m:r>
-                              <m:r>
-                                <a:rPr lang="en-US" sz="2400" b="0" i="0" smtClean="0">
-                                  <a:solidFill>
-                                    <a:schemeClr val="tx1"/>
-                                  </a:solidFill>
-                                  <a:latin typeface="Cambria Math" panose="02040503050406030204" pitchFamily="18" charset="0"/>
-                                </a:rPr>
-                                <m:t>1</m:t>
+                                <m:t>(1</m:t>
                               </m:r>
                             </m:oMath>
                           </a14:m>
@@ -25337,10 +25336,7 @@
                           </a:pPr>
                           <a14:m>
                             <m:oMathPara xmlns:m="http://schemas.openxmlformats.org/officeDocument/2006/math">
-                              <m:oMathParaPr>
-                                <m:jc m:val="centerGroup"/>
-                              </m:oMathParaPr>
-                              <m:oMath xmlns:m="http://schemas.openxmlformats.org/officeDocument/2006/math">
+                              <m:oMath>
                                 <m:r>
                                   <a:rPr lang="en-US" sz="2400" b="0" i="1" smtClean="0">
                                     <a:solidFill>
@@ -25362,7 +25358,7 @@
                                 <m:func>
                                   <m:funcPr>
                                     <m:ctrlPr>
-                                      <a:rPr lang="en-US" sz="2400" b="0" i="1" smtClean="0">
+                                      <a:rPr lang="en-US" sz="2400" b="0" i="0" smtClean="0">
                                         <a:solidFill>
                                           <a:schemeClr val="tx1"/>
                                         </a:solidFill>
@@ -25449,10 +25445,7 @@
                           </a:pPr>
                           <a14:m>
                             <m:oMathPara xmlns:m="http://schemas.openxmlformats.org/officeDocument/2006/math">
-                              <m:oMathParaPr>
-                                <m:jc m:val="centerGroup"/>
-                              </m:oMathParaPr>
-                              <m:oMath xmlns:m="http://schemas.openxmlformats.org/officeDocument/2006/math">
+                              <m:oMath>
                                 <m:r>
                                   <a:rPr lang="en-US" sz="2400" b="0" i="1" smtClean="0">
                                     <a:solidFill>
@@ -25474,7 +25467,7 @@
                                 <m:func>
                                   <m:funcPr>
                                     <m:ctrlPr>
-                                      <a:rPr lang="en-US" sz="2400" b="0" i="1" smtClean="0">
+                                      <a:rPr lang="en-US" sz="2400" b="0" i="0" smtClean="0">
                                         <a:solidFill>
                                           <a:schemeClr val="tx1"/>
                                         </a:solidFill>
@@ -25553,10 +25546,7 @@
                           </a:pPr>
                           <a14:m>
                             <m:oMathPara xmlns:m="http://schemas.openxmlformats.org/officeDocument/2006/math">
-                              <m:oMathParaPr>
-                                <m:jc m:val="centerGroup"/>
-                              </m:oMathParaPr>
-                              <m:oMath xmlns:m="http://schemas.openxmlformats.org/officeDocument/2006/math">
+                              <m:oMath>
                                 <m:r>
                                   <a:rPr lang="en-US" sz="2400" b="0" i="1" smtClean="0">
                                     <a:solidFill>
@@ -25578,7 +25568,7 @@
                                 <m:func>
                                   <m:funcPr>
                                     <m:ctrlPr>
-                                      <a:rPr lang="en-US" sz="2400" b="0" i="1" smtClean="0">
+                                      <a:rPr lang="en-US" sz="2400" b="0" i="0" smtClean="0">
                                         <a:solidFill>
                                           <a:schemeClr val="tx1"/>
                                         </a:solidFill>
@@ -25657,10 +25647,7 @@
                           </a:pPr>
                           <a14:m>
                             <m:oMathPara xmlns:m="http://schemas.openxmlformats.org/officeDocument/2006/math">
-                              <m:oMathParaPr>
-                                <m:jc m:val="centerGroup"/>
-                              </m:oMathParaPr>
-                              <m:oMath xmlns:m="http://schemas.openxmlformats.org/officeDocument/2006/math">
+                              <m:oMath>
                                 <m:r>
                                   <a:rPr lang="en-US" sz="2400" b="0" i="1" smtClean="0">
                                     <a:solidFill>
@@ -25755,16 +25742,7 @@
                                   </a:solidFill>
                                   <a:latin typeface="Cambria Math" panose="02040503050406030204" pitchFamily="18" charset="0"/>
                                 </a:rPr>
-                                <m:t>(</m:t>
-                              </m:r>
-                              <m:r>
-                                <a:rPr lang="en-US" sz="2400" b="0" i="0" smtClean="0">
-                                  <a:solidFill>
-                                    <a:schemeClr val="tx1"/>
-                                  </a:solidFill>
-                                  <a:latin typeface="Cambria Math" panose="02040503050406030204" pitchFamily="18" charset="0"/>
-                                </a:rPr>
-                                <m:t>1</m:t>
+                                <m:t>(1</m:t>
                               </m:r>
                             </m:oMath>
                           </a14:m>
@@ -26028,7 +26006,7 @@
             </a:graphic>
           </p:graphicFrame>
         </mc:Choice>
-        <mc:Fallback>
+        <mc:Fallback xmlns="">
           <p:graphicFrame>
             <p:nvGraphicFramePr>
               <p:cNvPr id="2" name="Table 3">
@@ -26822,7 +26800,7 @@
                       <a:rPr lang="en-US" b="0" i="1" smtClean="0">
                         <a:latin typeface="Cambria Math" panose="02040503050406030204" pitchFamily="18" charset="0"/>
                       </a:rPr>
-                      <m:t>h</m:t>
+                      <m:t>ℎ</m:t>
                     </m:r>
                   </m:oMath>
                 </a14:m>
@@ -26855,15 +26833,12 @@
                 </a:pPr>
                 <a14:m>
                   <m:oMathPara xmlns:m="http://schemas.openxmlformats.org/officeDocument/2006/math">
-                    <m:oMathParaPr>
-                      <m:jc m:val="centerGroup"/>
-                    </m:oMathParaPr>
-                    <m:oMath xmlns:m="http://schemas.openxmlformats.org/officeDocument/2006/math">
+                    <m:oMath>
                       <m:r>
                         <a:rPr lang="en-US" i="1">
                           <a:latin typeface="Cambria Math" panose="02040503050406030204" pitchFamily="18" charset="0"/>
                         </a:rPr>
-                        <m:t>h</m:t>
+                        <m:t>ℎ</m:t>
                       </m:r>
                       <m:r>
                         <a:rPr lang="en-US" i="1">
@@ -29564,14 +29539,11 @@
                 <a:pPr/>
                 <a14:m>
                   <m:oMathPara xmlns:m="http://schemas.openxmlformats.org/officeDocument/2006/math">
-                    <m:oMathParaPr>
-                      <m:jc m:val="centerGroup"/>
-                    </m:oMathParaPr>
-                    <m:oMath xmlns:m="http://schemas.openxmlformats.org/officeDocument/2006/math">
+                    <m:oMath>
                       <m:sSub>
                         <m:sSubPr>
                           <m:ctrlPr>
-                            <a:rPr lang="en-US" sz="2800" i="1" smtClean="0">
+                            <a:rPr lang="en-US" sz="2800" b="0" i="1" smtClean="0">
                               <a:latin typeface="Cambria Math" panose="02040503050406030204" pitchFamily="18" charset="0"/>
                             </a:rPr>
                           </m:ctrlPr>
@@ -29581,7 +29553,7 @@
                             <a:rPr lang="en-US" sz="2800" b="0" i="1" smtClean="0">
                               <a:latin typeface="Cambria Math" panose="02040503050406030204" pitchFamily="18" charset="0"/>
                             </a:rPr>
-                            <m:t>h</m:t>
+                            <m:t>ℎ</m:t>
                           </m:r>
                         </m:e>
                         <m:sub>
@@ -32436,14 +32408,11 @@
                 <a:pPr/>
                 <a14:m>
                   <m:oMathPara xmlns:m="http://schemas.openxmlformats.org/officeDocument/2006/math">
-                    <m:oMathParaPr>
-                      <m:jc m:val="centerGroup"/>
-                    </m:oMathParaPr>
-                    <m:oMath xmlns:m="http://schemas.openxmlformats.org/officeDocument/2006/math">
+                    <m:oMath>
                       <m:sSub>
                         <m:sSubPr>
                           <m:ctrlPr>
-                            <a:rPr lang="en-US" sz="2800" i="1" smtClean="0">
+                            <a:rPr lang="en-US" sz="2800" b="0" i="1" smtClean="0">
                               <a:latin typeface="Cambria Math" panose="02040503050406030204" pitchFamily="18" charset="0"/>
                             </a:rPr>
                           </m:ctrlPr>
@@ -32453,7 +32422,7 @@
                             <a:rPr lang="en-US" sz="2800" b="0" i="1" smtClean="0">
                               <a:latin typeface="Cambria Math" panose="02040503050406030204" pitchFamily="18" charset="0"/>
                             </a:rPr>
-                            <m:t>h</m:t>
+                            <m:t>ℎ</m:t>
                           </m:r>
                         </m:e>
                         <m:sub>
@@ -34567,7 +34536,7 @@
                 </a:pPr>
                 <a:r>
                   <a:rPr lang="en-US" sz="3200" dirty="0"/>
-                  <a:t>Commonly used </a:t>
+                  <a:t>Simple </a:t>
                 </a:r>
                 <a:r>
                   <a:rPr lang="en-US" sz="3200" b="1" dirty="0"/>
@@ -34607,10 +34576,7 @@
                 </a:pPr>
                 <a14:m>
                   <m:oMathPara xmlns:m="http://schemas.openxmlformats.org/officeDocument/2006/math">
-                    <m:oMathParaPr>
-                      <m:jc m:val="centerGroup"/>
-                    </m:oMathParaPr>
-                    <m:oMath xmlns:m="http://schemas.openxmlformats.org/officeDocument/2006/math">
+                    <m:oMath>
                       <m:r>
                         <m:rPr>
                           <m:sty m:val="p"/>
@@ -34623,7 +34589,7 @@
                       <m:d>
                         <m:dPr>
                           <m:ctrlPr>
-                            <a:rPr lang="en-US" sz="3000" i="1">
+                            <a:rPr lang="en-US" sz="3000" i="1" smtClean="0">
                               <a:latin typeface="Cambria Math" panose="02040503050406030204" pitchFamily="18" charset="0"/>
                             </a:rPr>
                           </m:ctrlPr>
@@ -34657,7 +34623,7 @@
                           <m:d>
                             <m:dPr>
                               <m:ctrlPr>
-                                <a:rPr lang="en-US" sz="3000" i="1" smtClean="0">
+                                <a:rPr lang="en-US" sz="3000" b="0" i="1" smtClean="0">
                                   <a:latin typeface="Cambria Math" panose="02040503050406030204" pitchFamily="18" charset="0"/>
                                 </a:rPr>
                               </m:ctrlPr>
@@ -34813,7 +34779,15 @@
                 <a:pPr lvl="1"/>
                 <a:r>
                   <a:rPr lang="en-US" sz="2600" dirty="0"/>
-                  <a:t>b = additive constant</a:t>
+                  <a:t>b </a:t>
+                </a:r>
+                <a:r>
+                  <a:rPr lang="en-US" sz="2600"/>
+                  <a:t>= optional additive </a:t>
+                </a:r>
+                <a:r>
+                  <a:rPr lang="en-US" sz="2600" dirty="0"/>
+                  <a:t>constant</a:t>
                 </a:r>
               </a:p>
               <a:p>
@@ -35068,8 +35042,8 @@
           <a:chExt cx="0" cy="0"/>
         </a:xfrm>
       </p:grpSpPr>
-      <mc:AlternateContent xmlns:mc="http://schemas.openxmlformats.org/markup-compatibility/2006" xmlns:a14="http://schemas.microsoft.com/office/drawing/2010/main">
-        <mc:Choice Requires="a14">
+      <mc:AlternateContent xmlns:mc="http://schemas.openxmlformats.org/markup-compatibility/2006">
+        <mc:Choice xmlns:a14="http://schemas.microsoft.com/office/drawing/2010/main" Requires="a14">
           <p:sp>
             <p:nvSpPr>
               <p:cNvPr id="3" name="Content Placeholder 2">
@@ -35103,7 +35077,7 @@
                 </a:pPr>
                 <a:r>
                   <a:rPr lang="en-US" sz="3200" dirty="0"/>
-                  <a:t>Commonly used </a:t>
+                  <a:t>Simple </a:t>
                 </a:r>
                 <a:r>
                   <a:rPr lang="en-US" sz="3200" b="1" dirty="0"/>
@@ -35117,12 +35091,8 @@
               </a:p>
               <a:p>
                 <a:r>
-                  <a:rPr lang="en-US" sz="3000"/>
-                  <a:t>Hash function is </a:t>
-                </a:r>
-                <a:r>
                   <a:rPr lang="en-US" sz="3000" dirty="0"/>
-                  <a:t>applied to a </a:t>
+                  <a:t>Hash function is applied to a </a:t>
                 </a:r>
                 <a:r>
                   <a:rPr lang="en-US" sz="3000" b="1" dirty="0"/>
@@ -35149,10 +35119,7 @@
                 </a:pPr>
                 <a14:m>
                   <m:oMathPara xmlns:m="http://schemas.openxmlformats.org/officeDocument/2006/math">
-                    <m:oMathParaPr>
-                      <m:jc m:val="centerGroup"/>
-                    </m:oMathParaPr>
-                    <m:oMath xmlns:m="http://schemas.openxmlformats.org/officeDocument/2006/math">
+                    <m:oMath>
                       <m:r>
                         <m:rPr>
                           <m:sty m:val="p"/>
@@ -35165,7 +35132,7 @@
                       <m:d>
                         <m:dPr>
                           <m:ctrlPr>
-                            <a:rPr lang="en-US" sz="3000" i="1">
+                            <a:rPr lang="en-US" sz="3000" i="1" smtClean="0">
                               <a:latin typeface="Cambria Math" panose="02040503050406030204" pitchFamily="18" charset="0"/>
                             </a:rPr>
                           </m:ctrlPr>
@@ -35199,7 +35166,7 @@
                           <m:d>
                             <m:dPr>
                               <m:ctrlPr>
-                                <a:rPr lang="en-US" sz="3000" i="1" smtClean="0">
+                                <a:rPr lang="en-US" sz="3000" b="0" i="1" smtClean="0">
                                   <a:latin typeface="Cambria Math" panose="02040503050406030204" pitchFamily="18" charset="0"/>
                                 </a:rPr>
                               </m:ctrlPr>
@@ -35310,10 +35277,7 @@
                 </a:pPr>
                 <a14:m>
                   <m:oMathPara xmlns:m="http://schemas.openxmlformats.org/officeDocument/2006/math">
-                    <m:oMathParaPr>
-                      <m:jc m:val="centerGroup"/>
-                    </m:oMathParaPr>
-                    <m:oMath xmlns:m="http://schemas.openxmlformats.org/officeDocument/2006/math">
+                    <m:oMath>
                       <m:r>
                         <m:rPr>
                           <m:sty m:val="p"/>
@@ -35444,7 +35408,7 @@
                     <m:sSub>
                       <m:sSubPr>
                         <m:ctrlPr>
-                          <a:rPr lang="en-US" sz="3000" i="1" smtClean="0">
+                          <a:rPr lang="en-US" sz="3000" b="0" i="1" smtClean="0">
                             <a:latin typeface="Cambria Math" panose="02040503050406030204" pitchFamily="18" charset="0"/>
                           </a:rPr>
                         </m:ctrlPr>
@@ -35454,7 +35418,7 @@
                           <a:rPr lang="en-US" sz="3000" b="0" i="1" smtClean="0">
                             <a:latin typeface="Cambria Math" panose="02040503050406030204" pitchFamily="18" charset="0"/>
                           </a:rPr>
-                          <m:t>h</m:t>
+                          <m:t>ℎ</m:t>
                         </m:r>
                       </m:e>
                       <m:sub>
@@ -35519,15 +35483,12 @@
                 </a:pPr>
                 <a14:m>
                   <m:oMathPara xmlns:m="http://schemas.openxmlformats.org/officeDocument/2006/math">
-                    <m:oMathParaPr>
-                      <m:jc m:val="centerGroup"/>
-                    </m:oMathParaPr>
-                    <m:oMath xmlns:m="http://schemas.openxmlformats.org/officeDocument/2006/math">
+                    <m:oMath>
                       <m:r>
                         <a:rPr lang="en-US" sz="3000" b="0" i="1" smtClean="0">
                           <a:latin typeface="Cambria Math" panose="02040503050406030204" pitchFamily="18" charset="0"/>
                         </a:rPr>
-                        <m:t>h</m:t>
+                        <m:t>ℎ</m:t>
                       </m:r>
                       <m:d>
                         <m:dPr>
@@ -35601,7 +35562,7 @@
                               <m:sSub>
                                 <m:sSubPr>
                                   <m:ctrlPr>
-                                    <a:rPr lang="en-US" sz="3000" i="1">
+                                    <a:rPr lang="en-US" sz="3000" b="0" i="1" smtClean="0">
                                       <a:latin typeface="Cambria Math" panose="02040503050406030204" pitchFamily="18" charset="0"/>
                                     </a:rPr>
                                   </m:ctrlPr>
@@ -35611,7 +35572,7 @@
                                     <a:rPr lang="en-US" sz="3000" b="0" i="1" smtClean="0">
                                       <a:latin typeface="Cambria Math" panose="02040503050406030204" pitchFamily="18" charset="0"/>
                                     </a:rPr>
-                                    <m:t>h</m:t>
+                                    <m:t>ℎ</m:t>
                                   </m:r>
                                 </m:e>
                                 <m:sub>
@@ -35709,7 +35670,7 @@
                           <a:rPr lang="en-US" sz="2800" i="1">
                             <a:latin typeface="Cambria Math" panose="02040503050406030204" pitchFamily="18" charset="0"/>
                           </a:rPr>
-                          <m:t>h</m:t>
+                          <m:t>ℎ</m:t>
                         </m:r>
                       </m:e>
                       <m:sub>
@@ -35770,7 +35731,7 @@
             </p:txBody>
           </p:sp>
         </mc:Choice>
-        <mc:Fallback xmlns="">
+        <mc:Fallback>
           <p:sp>
             <p:nvSpPr>
               <p:cNvPr id="3" name="Content Placeholder 2">
@@ -36360,10 +36321,7 @@
                 </a:pPr>
                 <a14:m>
                   <m:oMathPara xmlns:m="http://schemas.openxmlformats.org/officeDocument/2006/math">
-                    <m:oMathParaPr>
-                      <m:jc m:val="centerGroup"/>
-                    </m:oMathParaPr>
-                    <m:oMath xmlns:m="http://schemas.openxmlformats.org/officeDocument/2006/math">
+                    <m:oMath>
                       <m:r>
                         <a:rPr lang="en-US" b="1" i="1">
                           <a:latin typeface="Cambria Math" panose="02040503050406030204" pitchFamily="18" charset="0"/>
@@ -36476,10 +36434,7 @@
                 </a:pPr>
                 <a14:m>
                   <m:oMathPara xmlns:m="http://schemas.openxmlformats.org/officeDocument/2006/math">
-                    <m:oMathParaPr>
-                      <m:jc m:val="centerGroup"/>
-                    </m:oMathParaPr>
-                    <m:oMath xmlns:m="http://schemas.openxmlformats.org/officeDocument/2006/math">
+                    <m:oMath>
                       <m:r>
                         <m:rPr>
                           <m:sty m:val="p"/>
@@ -36492,7 +36447,7 @@
                       <m:d>
                         <m:dPr>
                           <m:ctrlPr>
-                            <a:rPr lang="en-US" i="1" smtClean="0">
+                            <a:rPr lang="en-US" b="0" i="1">
                               <a:latin typeface="Cambria Math" panose="02040503050406030204" pitchFamily="18" charset="0"/>
                             </a:rPr>
                           </m:ctrlPr>
@@ -36507,7 +36462,7 @@
                           <m:d>
                             <m:dPr>
                               <m:ctrlPr>
-                                <a:rPr lang="en-US" i="1">
+                                <a:rPr lang="en-US" b="0" i="1">
                                   <a:latin typeface="Cambria Math" panose="02040503050406030204" pitchFamily="18" charset="0"/>
                                 </a:rPr>
                               </m:ctrlPr>
@@ -36599,6 +36554,7 @@
                         <m:ctrlPr>
                           <a:rPr lang="en-US" i="1">
                             <a:latin typeface="Cambria Math" panose="02040503050406030204" pitchFamily="18" charset="0"/>
+                            <a:ea typeface="Cambria Math" panose="02040503050406030204" pitchFamily="18" charset="0"/>
                           </a:rPr>
                         </m:ctrlPr>
                       </m:sSupPr>
@@ -38922,10 +38878,7 @@
                 </a:pPr>
                 <a14:m>
                   <m:oMathPara xmlns:m="http://schemas.openxmlformats.org/officeDocument/2006/math">
-                    <m:oMathParaPr>
-                      <m:jc m:val="centerGroup"/>
-                    </m:oMathParaPr>
-                    <m:oMath xmlns:m="http://schemas.openxmlformats.org/officeDocument/2006/math">
+                    <m:oMath>
                       <m:r>
                         <a:rPr lang="en-US" b="1" i="1">
                           <a:latin typeface="Cambria Math" panose="02040503050406030204" pitchFamily="18" charset="0"/>
@@ -39038,10 +38991,7 @@
                 </a:pPr>
                 <a14:m>
                   <m:oMathPara xmlns:m="http://schemas.openxmlformats.org/officeDocument/2006/math">
-                    <m:oMathParaPr>
-                      <m:jc m:val="centerGroup"/>
-                    </m:oMathParaPr>
-                    <m:oMath xmlns:m="http://schemas.openxmlformats.org/officeDocument/2006/math">
+                    <m:oMath>
                       <m:r>
                         <m:rPr>
                           <m:sty m:val="p"/>
@@ -39054,7 +39004,7 @@
                       <m:d>
                         <m:dPr>
                           <m:ctrlPr>
-                            <a:rPr lang="en-US" i="1" smtClean="0">
+                            <a:rPr lang="en-US" b="0" i="1">
                               <a:latin typeface="Cambria Math" panose="02040503050406030204" pitchFamily="18" charset="0"/>
                             </a:rPr>
                           </m:ctrlPr>
@@ -39069,7 +39019,7 @@
                           <m:d>
                             <m:dPr>
                               <m:ctrlPr>
-                                <a:rPr lang="en-US" i="1">
+                                <a:rPr lang="en-US" b="0" i="1">
                                   <a:latin typeface="Cambria Math" panose="02040503050406030204" pitchFamily="18" charset="0"/>
                                 </a:rPr>
                               </m:ctrlPr>
@@ -39161,6 +39111,7 @@
                         <m:ctrlPr>
                           <a:rPr lang="en-US" i="1">
                             <a:latin typeface="Cambria Math" panose="02040503050406030204" pitchFamily="18" charset="0"/>
+                            <a:ea typeface="Cambria Math" panose="02040503050406030204" pitchFamily="18" charset="0"/>
                           </a:rPr>
                         </m:ctrlPr>
                       </m:sSupPr>
@@ -39231,10 +39182,7 @@
                 </a:pPr>
                 <a14:m>
                   <m:oMathPara xmlns:m="http://schemas.openxmlformats.org/officeDocument/2006/math">
-                    <m:oMathParaPr>
-                      <m:jc m:val="centerGroup"/>
-                    </m:oMathParaPr>
-                    <m:oMath xmlns:m="http://schemas.openxmlformats.org/officeDocument/2006/math">
+                    <m:oMath>
                       <m:r>
                         <a:rPr lang="en-US" b="0" i="1" smtClean="0">
                           <a:latin typeface="Cambria Math" panose="02040503050406030204" pitchFamily="18" charset="0"/>
@@ -39293,7 +39241,7 @@
                       <m:f>
                         <m:fPr>
                           <m:ctrlPr>
-                            <a:rPr lang="en-US" i="1">
+                            <a:rPr lang="en-US" b="0" i="1" smtClean="0">
                               <a:latin typeface="Cambria Math" panose="02040503050406030204" pitchFamily="18" charset="0"/>
                             </a:rPr>
                           </m:ctrlPr>
@@ -39853,10 +39801,7 @@
                 </a:pPr>
                 <a14:m>
                   <m:oMathPara xmlns:m="http://schemas.openxmlformats.org/officeDocument/2006/math">
-                    <m:oMathParaPr>
-                      <m:jc m:val="centerGroup"/>
-                    </m:oMathParaPr>
-                    <m:oMath xmlns:m="http://schemas.openxmlformats.org/officeDocument/2006/math">
+                    <m:oMath>
                       <m:r>
                         <a:rPr lang="en-US" i="1">
                           <a:latin typeface="Cambria Math" panose="02040503050406030204" pitchFamily="18" charset="0"/>
@@ -39997,14 +39942,11 @@
                 </a:pPr>
                 <a14:m>
                   <m:oMathPara xmlns:m="http://schemas.openxmlformats.org/officeDocument/2006/math">
-                    <m:oMathParaPr>
-                      <m:jc m:val="centerGroup"/>
-                    </m:oMathParaPr>
-                    <m:oMath xmlns:m="http://schemas.openxmlformats.org/officeDocument/2006/math">
+                    <m:oMath>
                       <m:sSub>
                         <m:sSubPr>
                           <m:ctrlPr>
-                            <a:rPr lang="en-US" i="1" smtClean="0">
+                            <a:rPr lang="en-US" b="0" i="1" smtClean="0">
                               <a:latin typeface="Cambria Math" panose="02040503050406030204" pitchFamily="18" charset="0"/>
                               <a:ea typeface="Cambria Math" panose="02040503050406030204" pitchFamily="18" charset="0"/>
                             </a:rPr>
@@ -40046,7 +39988,7 @@
                       <m:f>
                         <m:fPr>
                           <m:ctrlPr>
-                            <a:rPr lang="en-US" i="1">
+                            <a:rPr lang="en-US" b="0" i="1" smtClean="0">
                               <a:latin typeface="Cambria Math" panose="02040503050406030204" pitchFamily="18" charset="0"/>
                             </a:rPr>
                           </m:ctrlPr>
@@ -40080,8 +40022,9 @@
                           <m:f>
                             <m:fPr>
                               <m:ctrlPr>
-                                <a:rPr lang="en-US" i="1" smtClean="0">
+                                <a:rPr lang="en-US" i="1">
                                   <a:latin typeface="Cambria Math" panose="02040503050406030204" pitchFamily="18" charset="0"/>
+                                  <a:ea typeface="Cambria Math" panose="02040503050406030204" pitchFamily="18" charset="0"/>
                                 </a:rPr>
                               </m:ctrlPr>
                             </m:fPr>
@@ -41333,14 +41276,11 @@
                 </a:pPr>
                 <a14:m>
                   <m:oMathPara xmlns:m="http://schemas.openxmlformats.org/officeDocument/2006/math">
-                    <m:oMathParaPr>
-                      <m:jc m:val="centerGroup"/>
-                    </m:oMathParaPr>
-                    <m:oMath xmlns:m="http://schemas.openxmlformats.org/officeDocument/2006/math">
+                    <m:oMath>
                       <m:sSub>
                         <m:sSubPr>
                           <m:ctrlPr>
-                            <a:rPr lang="en-US" i="1" smtClean="0">
+                            <a:rPr lang="en-US" b="0" i="1" smtClean="0">
                               <a:latin typeface="Cambria Math" panose="02040503050406030204" pitchFamily="18" charset="0"/>
                               <a:ea typeface="Cambria Math" panose="02040503050406030204" pitchFamily="18" charset="0"/>
                             </a:rPr>
@@ -41382,7 +41322,7 @@
                       <m:f>
                         <m:fPr>
                           <m:ctrlPr>
-                            <a:rPr lang="en-US" i="1">
+                            <a:rPr lang="en-US" b="0" i="1" smtClean="0">
                               <a:latin typeface="Cambria Math" panose="02040503050406030204" pitchFamily="18" charset="0"/>
                             </a:rPr>
                           </m:ctrlPr>
@@ -41416,8 +41356,9 @@
                           <m:f>
                             <m:fPr>
                               <m:ctrlPr>
-                                <a:rPr lang="en-US" i="1" smtClean="0">
+                                <a:rPr lang="en-US" i="1">
                                   <a:latin typeface="Cambria Math" panose="02040503050406030204" pitchFamily="18" charset="0"/>
+                                  <a:ea typeface="Cambria Math" panose="02040503050406030204" pitchFamily="18" charset="0"/>
                                 </a:rPr>
                               </m:ctrlPr>
                             </m:fPr>
@@ -41838,10 +41779,7 @@
                 </a:pPr>
                 <a14:m>
                   <m:oMathPara xmlns:m="http://schemas.openxmlformats.org/officeDocument/2006/math">
-                    <m:oMathParaPr>
-                      <m:jc m:val="centerGroup"/>
-                    </m:oMathParaPr>
-                    <m:oMath xmlns:m="http://schemas.openxmlformats.org/officeDocument/2006/math">
+                    <m:oMath>
                       <m:r>
                         <a:rPr lang="en-US" i="1">
                           <a:latin typeface="Cambria Math" panose="02040503050406030204" pitchFamily="18" charset="0"/>
@@ -41979,10 +41917,7 @@
                 </a:pPr>
                 <a14:m>
                   <m:oMathPara xmlns:m="http://schemas.openxmlformats.org/officeDocument/2006/math">
-                    <m:oMathParaPr>
-                      <m:jc m:val="centerGroup"/>
-                    </m:oMathParaPr>
-                    <m:oMath xmlns:m="http://schemas.openxmlformats.org/officeDocument/2006/math">
+                    <m:oMath>
                       <m:r>
                         <a:rPr lang="en-US" b="0" i="1" smtClean="0">
                           <a:latin typeface="Cambria Math" panose="02040503050406030204" pitchFamily="18" charset="0"/>
@@ -42609,25 +42544,28 @@
           <a:p>
             <a:r>
               <a:rPr lang="en-US" dirty="0"/>
-              <a:t>Knowledge discovery requires </a:t>
-            </a:r>
-            <a:r>
-              <a:rPr lang="en-US" b="1" dirty="0"/>
-              <a:t>inference</a:t>
+              <a:t>Hash functions provide direct addressing at a massive scale</a:t>
             </a:r>
           </a:p>
           <a:p>
             <a:pPr lvl="1"/>
             <a:r>
               <a:rPr lang="en-US" dirty="0"/>
-              <a:t>Inference for complex data must control false discovery rate</a:t>
+              <a:t>Ideal hash functions should have uniform distribution of hash values </a:t>
             </a:r>
           </a:p>
           <a:p>
             <a:pPr lvl="1"/>
             <a:r>
               <a:rPr lang="en-US" dirty="0"/>
-              <a:t>Must limit Type II error with FDR controls</a:t>
+              <a:t>Hash collisions are expected and must be managed  </a:t>
+            </a:r>
+          </a:p>
+          <a:p>
+            <a:pPr lvl="1"/>
+            <a:r>
+              <a:rPr lang="en-US" dirty="0"/>
+              <a:t>Hash tables require resizing algorithms </a:t>
             </a:r>
           </a:p>
         </p:txBody>
@@ -43919,7 +43857,7 @@
               <a:rPr lang="en-US" sz="2800" b="0" dirty="0">
                 <a:cs typeface="Arial" panose="020B0604020202020204" pitchFamily="34" charset="0"/>
               </a:rPr>
-              <a:t>Lead team that commercialized Bell Labs S, now opensource R</a:t>
+              <a:t>Led team that commercialized Bell Labs S, now opensource R</a:t>
             </a:r>
           </a:p>
           <a:p>

</xml_diff>

<commit_message>
Corrected typo from lecture
</commit_message>
<xml_diff>
--- a/slides/1_Introduction.pptx
+++ b/slides/1_Introduction.pptx
@@ -34779,15 +34779,7 @@
                 <a:pPr lvl="1"/>
                 <a:r>
                   <a:rPr lang="en-US" sz="2600" dirty="0"/>
-                  <a:t>b </a:t>
-                </a:r>
-                <a:r>
-                  <a:rPr lang="en-US" sz="2600"/>
-                  <a:t>= optional additive </a:t>
-                </a:r>
-                <a:r>
-                  <a:rPr lang="en-US" sz="2600" dirty="0"/>
-                  <a:t>constant</a:t>
+                  <a:t>b = optional additive constant</a:t>
                 </a:r>
               </a:p>
               <a:p>
@@ -35401,7 +35393,7 @@
               <a:p>
                 <a:r>
                   <a:rPr lang="en-US" sz="3000" dirty="0"/>
-                  <a:t>We can sum the hashes, </a:t>
+                  <a:t>We can sum the binary hashes, </a:t>
                 </a:r>
                 <a14:m>
                   <m:oMath xmlns:m="http://schemas.openxmlformats.org/officeDocument/2006/math">
@@ -38193,121 +38185,180 @@
           <a:chExt cx="0" cy="0"/>
         </a:xfrm>
       </p:grpSpPr>
-      <p:sp>
-        <p:nvSpPr>
-          <p:cNvPr id="3" name="Content Placeholder 2">
-            <a:extLst>
-              <a:ext uri="{FF2B5EF4-FFF2-40B4-BE49-F238E27FC236}">
-                <a16:creationId xmlns:a16="http://schemas.microsoft.com/office/drawing/2014/main" id="{258E6AF3-7615-4BD1-878E-A94C93E98F90}"/>
-              </a:ext>
-            </a:extLst>
-          </p:cNvPr>
-          <p:cNvSpPr>
-            <a:spLocks noGrp="1"/>
-          </p:cNvSpPr>
-          <p:nvPr>
-            <p:ph idx="1"/>
-          </p:nvPr>
-        </p:nvSpPr>
-        <p:spPr>
-          <a:xfrm>
-            <a:off x="838199" y="1123406"/>
-            <a:ext cx="5431971" cy="5470724"/>
-          </a:xfrm>
-        </p:spPr>
-        <p:txBody>
-          <a:bodyPr>
-            <a:normAutofit/>
-          </a:bodyPr>
-          <a:lstStyle/>
-          <a:p>
-            <a:pPr marL="0" indent="0">
-              <a:buNone/>
-            </a:pPr>
-            <a:r>
-              <a:rPr lang="en-US" dirty="0"/>
-              <a:t>Resolving hash key collisions   </a:t>
-            </a:r>
-          </a:p>
-          <a:p>
-            <a:r>
-              <a:rPr lang="en-US" b="1" dirty="0">
-                <a:hlinkClick r:id="rId2"/>
-              </a:rPr>
-              <a:t>Open addressing </a:t>
-            </a:r>
-            <a:r>
-              <a:rPr lang="en-US" dirty="0"/>
-              <a:t>methods widely used</a:t>
-            </a:r>
-          </a:p>
-          <a:p>
-            <a:r>
-              <a:rPr lang="en-US" dirty="0"/>
-              <a:t>Key collisions resolved by </a:t>
-            </a:r>
-            <a:r>
-              <a:rPr lang="en-US" b="1" dirty="0"/>
-              <a:t>probing</a:t>
-            </a:r>
-            <a:r>
-              <a:rPr lang="en-US" dirty="0"/>
-              <a:t> for open bucket</a:t>
-            </a:r>
-          </a:p>
-          <a:p>
-            <a:pPr lvl="1"/>
-            <a:r>
-              <a:rPr lang="en-US" b="1" dirty="0">
-                <a:hlinkClick r:id="rId3"/>
-              </a:rPr>
-              <a:t>Linear probing </a:t>
-            </a:r>
-            <a:r>
-              <a:rPr lang="en-US" dirty="0"/>
-              <a:t>– search buckets in order – efficient and widely used</a:t>
-            </a:r>
-          </a:p>
-          <a:p>
-            <a:pPr lvl="1"/>
-            <a:r>
-              <a:rPr lang="en-US" dirty="0"/>
-              <a:t>Quadratic probing – increases interval between buckets searched</a:t>
-            </a:r>
-          </a:p>
-          <a:p>
-            <a:pPr lvl="1"/>
-            <a:r>
-              <a:rPr lang="en-US" dirty="0"/>
-              <a:t>Double hashing – search for open bucket with second hash</a:t>
-            </a:r>
-          </a:p>
-          <a:p>
-            <a:r>
-              <a:rPr lang="en-US" dirty="0"/>
-              <a:t>Searching colliding keys </a:t>
-            </a:r>
-            <a:r>
-              <a:rPr lang="en-US"/>
-              <a:t>in greater </a:t>
-            </a:r>
-            <a:r>
-              <a:rPr lang="en-US" dirty="0"/>
-              <a:t>than linear time</a:t>
-            </a:r>
-          </a:p>
-          <a:p>
-            <a:pPr marL="0" indent="0">
-              <a:buNone/>
-            </a:pPr>
-            <a:endParaRPr lang="en-US" dirty="0"/>
-          </a:p>
-          <a:p>
-            <a:pPr lvl="1"/>
-            <a:endParaRPr lang="en-US" sz="2200" dirty="0"/>
-          </a:p>
-        </p:txBody>
-      </p:sp>
+      <mc:AlternateContent xmlns:mc="http://schemas.openxmlformats.org/markup-compatibility/2006">
+        <mc:Choice xmlns:a14="http://schemas.microsoft.com/office/drawing/2010/main" Requires="a14">
+          <p:sp>
+            <p:nvSpPr>
+              <p:cNvPr id="3" name="Content Placeholder 2">
+                <a:extLst>
+                  <a:ext uri="{FF2B5EF4-FFF2-40B4-BE49-F238E27FC236}">
+                    <a16:creationId xmlns:a16="http://schemas.microsoft.com/office/drawing/2014/main" id="{258E6AF3-7615-4BD1-878E-A94C93E98F90}"/>
+                  </a:ext>
+                </a:extLst>
+              </p:cNvPr>
+              <p:cNvSpPr>
+                <a:spLocks noGrp="1"/>
+              </p:cNvSpPr>
+              <p:nvPr>
+                <p:ph idx="1"/>
+              </p:nvPr>
+            </p:nvSpPr>
+            <p:spPr>
+              <a:xfrm>
+                <a:off x="838199" y="1123406"/>
+                <a:ext cx="5431971" cy="5470724"/>
+              </a:xfrm>
+            </p:spPr>
+            <p:txBody>
+              <a:bodyPr>
+                <a:normAutofit/>
+              </a:bodyPr>
+              <a:lstStyle/>
+              <a:p>
+                <a:pPr marL="0" indent="0">
+                  <a:buNone/>
+                </a:pPr>
+                <a:r>
+                  <a:rPr lang="en-US" dirty="0"/>
+                  <a:t>Resolving hash key collisions   </a:t>
+                </a:r>
+              </a:p>
+              <a:p>
+                <a:r>
+                  <a:rPr lang="en-US" b="1" dirty="0">
+                    <a:hlinkClick r:id="rId2"/>
+                  </a:rPr>
+                  <a:t>Open addressing </a:t>
+                </a:r>
+                <a:r>
+                  <a:rPr lang="en-US" dirty="0"/>
+                  <a:t>methods widely used</a:t>
+                </a:r>
+              </a:p>
+              <a:p>
+                <a:r>
+                  <a:rPr lang="en-US" dirty="0"/>
+                  <a:t>Key collisions resolved by </a:t>
+                </a:r>
+                <a:r>
+                  <a:rPr lang="en-US" b="1" dirty="0"/>
+                  <a:t>probing</a:t>
+                </a:r>
+                <a:r>
+                  <a:rPr lang="en-US" dirty="0"/>
+                  <a:t> for open bucket</a:t>
+                </a:r>
+              </a:p>
+              <a:p>
+                <a:pPr lvl="1"/>
+                <a:r>
+                  <a:rPr lang="en-US" b="1" dirty="0">
+                    <a:hlinkClick r:id="rId3"/>
+                  </a:rPr>
+                  <a:t>Linear probing </a:t>
+                </a:r>
+                <a:r>
+                  <a:rPr lang="en-US" dirty="0"/>
+                  <a:t>– search buckets in order – efficient and widely used</a:t>
+                </a:r>
+              </a:p>
+              <a:p>
+                <a:pPr lvl="1"/>
+                <a:r>
+                  <a:rPr lang="en-US" dirty="0"/>
+                  <a:t>Quadratic probing – increases interval between buckets searched</a:t>
+                </a:r>
+              </a:p>
+              <a:p>
+                <a:pPr lvl="1"/>
+                <a:r>
+                  <a:rPr lang="en-US" dirty="0"/>
+                  <a:t>Double hashing – search for open bucket with second hash</a:t>
+                </a:r>
+              </a:p>
+              <a:p>
+                <a:r>
+                  <a:rPr lang="en-US" dirty="0"/>
+                  <a:t>Searching colliding keys in greater than </a:t>
+                </a:r>
+                <a14:m>
+                  <m:oMath xmlns:m="http://schemas.openxmlformats.org/officeDocument/2006/math">
+                    <m:r>
+                      <a:rPr lang="en-US" b="0" i="1" smtClean="0">
+                        <a:latin typeface="Cambria Math" panose="02040503050406030204" pitchFamily="18" charset="0"/>
+                      </a:rPr>
+                      <m:t>𝑂</m:t>
+                    </m:r>
+                    <m:r>
+                      <a:rPr lang="en-US" b="0" i="1" smtClean="0">
+                        <a:latin typeface="Cambria Math" panose="02040503050406030204" pitchFamily="18" charset="0"/>
+                      </a:rPr>
+                      <m:t>(1)</m:t>
+                    </m:r>
+                  </m:oMath>
+                </a14:m>
+                <a:r>
+                  <a:rPr lang="en-US" dirty="0"/>
+                  <a:t> time</a:t>
+                </a:r>
+              </a:p>
+              <a:p>
+                <a:pPr marL="0" indent="0">
+                  <a:buNone/>
+                </a:pPr>
+                <a:endParaRPr lang="en-US" dirty="0"/>
+              </a:p>
+              <a:p>
+                <a:pPr lvl="1"/>
+                <a:endParaRPr lang="en-US" sz="2200" dirty="0"/>
+              </a:p>
+            </p:txBody>
+          </p:sp>
+        </mc:Choice>
+        <mc:Fallback>
+          <p:sp>
+            <p:nvSpPr>
+              <p:cNvPr id="3" name="Content Placeholder 2">
+                <a:extLst>
+                  <a:ext uri="{FF2B5EF4-FFF2-40B4-BE49-F238E27FC236}">
+                    <a16:creationId xmlns:a16="http://schemas.microsoft.com/office/drawing/2014/main" id="{258E6AF3-7615-4BD1-878E-A94C93E98F90}"/>
+                  </a:ext>
+                </a:extLst>
+              </p:cNvPr>
+              <p:cNvSpPr>
+                <a:spLocks noGrp="1" noRot="1" noChangeAspect="1" noMove="1" noResize="1" noEditPoints="1" noAdjustHandles="1" noChangeArrowheads="1" noChangeShapeType="1" noTextEdit="1"/>
+              </p:cNvSpPr>
+              <p:nvPr>
+                <p:ph idx="1"/>
+              </p:nvPr>
+            </p:nvSpPr>
+            <p:spPr>
+              <a:xfrm>
+                <a:off x="838199" y="1123406"/>
+                <a:ext cx="5431971" cy="5470724"/>
+              </a:xfrm>
+              <a:blipFill>
+                <a:blip r:embed="rId4"/>
+                <a:stretch>
+                  <a:fillRect l="-2242" t="-1782" r="-785" b="-557"/>
+                </a:stretch>
+              </a:blipFill>
+            </p:spPr>
+            <p:txBody>
+              <a:bodyPr/>
+              <a:lstStyle/>
+              <a:p>
+                <a:r>
+                  <a:rPr lang="en-US">
+                    <a:noFill/>
+                  </a:rPr>
+                  <a:t> </a:t>
+                </a:r>
+              </a:p>
+            </p:txBody>
+          </p:sp>
+        </mc:Fallback>
+      </mc:AlternateContent>
       <p:sp>
         <p:nvSpPr>
           <p:cNvPr id="6" name="Title 1">
@@ -38395,7 +38446,7 @@
             <a:pPr algn="ctr"/>
             <a:r>
               <a:rPr lang="en-US" dirty="0">
-                <a:hlinkClick r:id="rId4"/>
+                <a:hlinkClick r:id="rId5"/>
               </a:rPr>
               <a:t>Credit: Wikipedia commons</a:t>
             </a:r>
@@ -38418,7 +38469,7 @@
           <p:nvPr/>
         </p:nvPicPr>
         <p:blipFill>
-          <a:blip r:embed="rId5"/>
+          <a:blip r:embed="rId6"/>
           <a:stretch>
             <a:fillRect/>
           </a:stretch>
@@ -38455,6 +38506,9 @@
                     <p:cTn id="3" fill="hold">
                       <p:stCondLst>
                         <p:cond delay="indefinite"/>
+                        <p:cond evt="onBegin" delay="0">
+                          <p:tn val="2"/>
+                        </p:cond>
                       </p:stCondLst>
                       <p:childTnLst>
                         <p:par>
@@ -38464,7 +38518,7 @@
                             </p:stCondLst>
                             <p:childTnLst>
                               <p:par>
-                                <p:cTn id="5" presetID="1" presetClass="entr" presetSubtype="0" fill="hold" nodeType="clickEffect">
+                                <p:cTn id="5" presetID="1" presetClass="entr" presetSubtype="0" fill="hold" nodeType="withEffect">
                                   <p:stCondLst>
                                     <p:cond delay="0"/>
                                   </p:stCondLst>
@@ -38472,117 +38526,6 @@
                                     <p:set>
                                       <p:cBhvr>
                                         <p:cTn id="6" dur="1" fill="hold">
-                                          <p:stCondLst>
-                                            <p:cond delay="0"/>
-                                          </p:stCondLst>
-                                        </p:cTn>
-                                        <p:tgtEl>
-                                          <p:spTgt spid="3">
-                                            <p:txEl>
-                                              <p:pRg st="1" end="1"/>
-                                            </p:txEl>
-                                          </p:spTgt>
-                                        </p:tgtEl>
-                                        <p:attrNameLst>
-                                          <p:attrName>style.visibility</p:attrName>
-                                        </p:attrNameLst>
-                                      </p:cBhvr>
-                                      <p:to>
-                                        <p:strVal val="visible"/>
-                                      </p:to>
-                                    </p:set>
-                                  </p:childTnLst>
-                                </p:cTn>
-                              </p:par>
-                            </p:childTnLst>
-                          </p:cTn>
-                        </p:par>
-                      </p:childTnLst>
-                    </p:cTn>
-                  </p:par>
-                  <p:par>
-                    <p:cTn id="7" fill="hold">
-                      <p:stCondLst>
-                        <p:cond delay="indefinite"/>
-                      </p:stCondLst>
-                      <p:childTnLst>
-                        <p:par>
-                          <p:cTn id="8" fill="hold">
-                            <p:stCondLst>
-                              <p:cond delay="0"/>
-                            </p:stCondLst>
-                            <p:childTnLst>
-                              <p:par>
-                                <p:cTn id="9" presetID="1" presetClass="entr" presetSubtype="0" fill="hold" nodeType="clickEffect">
-                                  <p:stCondLst>
-                                    <p:cond delay="0"/>
-                                  </p:stCondLst>
-                                  <p:childTnLst>
-                                    <p:set>
-                                      <p:cBhvr>
-                                        <p:cTn id="10" dur="1" fill="hold">
-                                          <p:stCondLst>
-                                            <p:cond delay="0"/>
-                                          </p:stCondLst>
-                                        </p:cTn>
-                                        <p:tgtEl>
-                                          <p:spTgt spid="3">
-                                            <p:txEl>
-                                              <p:pRg st="2" end="2"/>
-                                            </p:txEl>
-                                          </p:spTgt>
-                                        </p:tgtEl>
-                                        <p:attrNameLst>
-                                          <p:attrName>style.visibility</p:attrName>
-                                        </p:attrNameLst>
-                                      </p:cBhvr>
-                                      <p:to>
-                                        <p:strVal val="visible"/>
-                                      </p:to>
-                                    </p:set>
-                                  </p:childTnLst>
-                                </p:cTn>
-                              </p:par>
-                              <p:par>
-                                <p:cTn id="11" presetID="1" presetClass="entr" presetSubtype="0" fill="hold" nodeType="withEffect">
-                                  <p:stCondLst>
-                                    <p:cond delay="0"/>
-                                  </p:stCondLst>
-                                  <p:childTnLst>
-                                    <p:set>
-                                      <p:cBhvr>
-                                        <p:cTn id="12" dur="1" fill="hold">
-                                          <p:stCondLst>
-                                            <p:cond delay="0"/>
-                                          </p:stCondLst>
-                                        </p:cTn>
-                                        <p:tgtEl>
-                                          <p:spTgt spid="3">
-                                            <p:txEl>
-                                              <p:pRg st="3" end="3"/>
-                                            </p:txEl>
-                                          </p:spTgt>
-                                        </p:tgtEl>
-                                        <p:attrNameLst>
-                                          <p:attrName>style.visibility</p:attrName>
-                                        </p:attrNameLst>
-                                      </p:cBhvr>
-                                      <p:to>
-                                        <p:strVal val="visible"/>
-                                      </p:to>
-                                    </p:set>
-                                  </p:childTnLst>
-                                </p:cTn>
-                              </p:par>
-                              <p:par>
-                                <p:cTn id="13" presetID="1" presetClass="entr" presetSubtype="0" fill="hold" nodeType="withEffect">
-                                  <p:stCondLst>
-                                    <p:cond delay="0"/>
-                                  </p:stCondLst>
-                                  <p:childTnLst>
-                                    <p:set>
-                                      <p:cBhvr>
-                                        <p:cTn id="14" dur="1" fill="hold">
                                           <p:stCondLst>
                                             <p:cond delay="0"/>
                                           </p:stCondLst>
@@ -38602,131 +38545,20 @@
                                 </p:cTn>
                               </p:par>
                               <p:par>
-                                <p:cTn id="15" presetID="1" presetClass="entr" presetSubtype="0" fill="hold" grpId="0" nodeType="withEffect">
+                                <p:cTn id="7" presetID="1" presetClass="entr" presetSubtype="0" fill="hold" grpId="0" nodeType="withEffect">
                                   <p:stCondLst>
                                     <p:cond delay="0"/>
                                   </p:stCondLst>
                                   <p:childTnLst>
                                     <p:set>
                                       <p:cBhvr>
-                                        <p:cTn id="16" dur="1" fill="hold">
+                                        <p:cTn id="8" dur="1" fill="hold">
                                           <p:stCondLst>
                                             <p:cond delay="0"/>
                                           </p:stCondLst>
                                         </p:cTn>
                                         <p:tgtEl>
                                           <p:spTgt spid="5"/>
-                                        </p:tgtEl>
-                                        <p:attrNameLst>
-                                          <p:attrName>style.visibility</p:attrName>
-                                        </p:attrNameLst>
-                                      </p:cBhvr>
-                                      <p:to>
-                                        <p:strVal val="visible"/>
-                                      </p:to>
-                                    </p:set>
-                                  </p:childTnLst>
-                                </p:cTn>
-                              </p:par>
-                              <p:par>
-                                <p:cTn id="17" presetID="1" presetClass="entr" presetSubtype="0" fill="hold" nodeType="withEffect">
-                                  <p:stCondLst>
-                                    <p:cond delay="0"/>
-                                  </p:stCondLst>
-                                  <p:childTnLst>
-                                    <p:set>
-                                      <p:cBhvr>
-                                        <p:cTn id="18" dur="1" fill="hold">
-                                          <p:stCondLst>
-                                            <p:cond delay="0"/>
-                                          </p:stCondLst>
-                                        </p:cTn>
-                                        <p:tgtEl>
-                                          <p:spTgt spid="3">
-                                            <p:txEl>
-                                              <p:pRg st="4" end="4"/>
-                                            </p:txEl>
-                                          </p:spTgt>
-                                        </p:tgtEl>
-                                        <p:attrNameLst>
-                                          <p:attrName>style.visibility</p:attrName>
-                                        </p:attrNameLst>
-                                      </p:cBhvr>
-                                      <p:to>
-                                        <p:strVal val="visible"/>
-                                      </p:to>
-                                    </p:set>
-                                  </p:childTnLst>
-                                </p:cTn>
-                              </p:par>
-                              <p:par>
-                                <p:cTn id="19" presetID="1" presetClass="entr" presetSubtype="0" fill="hold" nodeType="withEffect">
-                                  <p:stCondLst>
-                                    <p:cond delay="0"/>
-                                  </p:stCondLst>
-                                  <p:childTnLst>
-                                    <p:set>
-                                      <p:cBhvr>
-                                        <p:cTn id="20" dur="1" fill="hold">
-                                          <p:stCondLst>
-                                            <p:cond delay="0"/>
-                                          </p:stCondLst>
-                                        </p:cTn>
-                                        <p:tgtEl>
-                                          <p:spTgt spid="3">
-                                            <p:txEl>
-                                              <p:pRg st="5" end="5"/>
-                                            </p:txEl>
-                                          </p:spTgt>
-                                        </p:tgtEl>
-                                        <p:attrNameLst>
-                                          <p:attrName>style.visibility</p:attrName>
-                                        </p:attrNameLst>
-                                      </p:cBhvr>
-                                      <p:to>
-                                        <p:strVal val="visible"/>
-                                      </p:to>
-                                    </p:set>
-                                  </p:childTnLst>
-                                </p:cTn>
-                              </p:par>
-                            </p:childTnLst>
-                          </p:cTn>
-                        </p:par>
-                      </p:childTnLst>
-                    </p:cTn>
-                  </p:par>
-                  <p:par>
-                    <p:cTn id="21" fill="hold">
-                      <p:stCondLst>
-                        <p:cond delay="indefinite"/>
-                      </p:stCondLst>
-                      <p:childTnLst>
-                        <p:par>
-                          <p:cTn id="22" fill="hold">
-                            <p:stCondLst>
-                              <p:cond delay="0"/>
-                            </p:stCondLst>
-                            <p:childTnLst>
-                              <p:par>
-                                <p:cTn id="23" presetID="1" presetClass="entr" presetSubtype="0" fill="hold" nodeType="clickEffect">
-                                  <p:stCondLst>
-                                    <p:cond delay="0"/>
-                                  </p:stCondLst>
-                                  <p:childTnLst>
-                                    <p:set>
-                                      <p:cBhvr>
-                                        <p:cTn id="24" dur="1" fill="hold">
-                                          <p:stCondLst>
-                                            <p:cond delay="0"/>
-                                          </p:stCondLst>
-                                        </p:cTn>
-                                        <p:tgtEl>
-                                          <p:spTgt spid="3">
-                                            <p:txEl>
-                                              <p:pRg st="6" end="6"/>
-                                            </p:txEl>
-                                          </p:spTgt>
                                         </p:tgtEl>
                                         <p:attrNameLst>
                                           <p:attrName>style.visibility</p:attrName>
@@ -42568,6 +42400,13 @@
               <a:t>Hash tables require resizing algorithms </a:t>
             </a:r>
           </a:p>
+          <a:p>
+            <a:pPr lvl="1"/>
+            <a:r>
+              <a:rPr lang="en-US" dirty="0"/>
+              <a:t>Merging is a key operation for hash tables. </a:t>
+            </a:r>
+          </a:p>
         </p:txBody>
       </p:sp>
       <p:sp>

</xml_diff>